<commit_message>
vault backup: 2026-05-17 07:59:01
</commit_message>
<xml_diff>
--- a/01_Courses/01_Active/00_BSKT/01_Quan Tri Hoc/07_AI-Workspace/Outputs/thuyet-trinh-bien-dong-gia.pptx
+++ b/01_Courses/01_Active/00_BSKT/01_Quan Tri Hoc/07_AI-Workspace/Outputs/thuyet-trinh-bien-dong-gia.pptx
@@ -311,7 +311,7 @@
           <a:p>
             <a:fld id="{5BCAD085-E8A6-8845-BD4E-CB4CCA059FC4}" type="datetimeFigureOut">
               <a:rPr lang="en-US" smtClean="0"/>
-              <a:t>5/16/2026</a:t>
+              <a:t>5/17/2026</a:t>
             </a:fld>
             <a:endParaRPr lang="en-US"/>
           </a:p>
@@ -479,7 +479,7 @@
           <a:p>
             <a:fld id="{5BCAD085-E8A6-8845-BD4E-CB4CCA059FC4}" type="datetimeFigureOut">
               <a:rPr lang="en-US" smtClean="0"/>
-              <a:t>5/16/2026</a:t>
+              <a:t>5/17/2026</a:t>
             </a:fld>
             <a:endParaRPr lang="en-US"/>
           </a:p>
@@ -657,7 +657,7 @@
           <a:p>
             <a:fld id="{5BCAD085-E8A6-8845-BD4E-CB4CCA059FC4}" type="datetimeFigureOut">
               <a:rPr lang="en-US" smtClean="0"/>
-              <a:t>5/16/2026</a:t>
+              <a:t>5/17/2026</a:t>
             </a:fld>
             <a:endParaRPr lang="en-US"/>
           </a:p>
@@ -825,7 +825,7 @@
           <a:p>
             <a:fld id="{5BCAD085-E8A6-8845-BD4E-CB4CCA059FC4}" type="datetimeFigureOut">
               <a:rPr lang="en-US" smtClean="0"/>
-              <a:t>5/16/2026</a:t>
+              <a:t>5/17/2026</a:t>
             </a:fld>
             <a:endParaRPr lang="en-US"/>
           </a:p>
@@ -1070,7 +1070,7 @@
           <a:p>
             <a:fld id="{5BCAD085-E8A6-8845-BD4E-CB4CCA059FC4}" type="datetimeFigureOut">
               <a:rPr lang="en-US" smtClean="0"/>
-              <a:t>5/16/2026</a:t>
+              <a:t>5/17/2026</a:t>
             </a:fld>
             <a:endParaRPr lang="en-US"/>
           </a:p>
@@ -1355,7 +1355,7 @@
           <a:p>
             <a:fld id="{5BCAD085-E8A6-8845-BD4E-CB4CCA059FC4}" type="datetimeFigureOut">
               <a:rPr lang="en-US" smtClean="0"/>
-              <a:t>5/16/2026</a:t>
+              <a:t>5/17/2026</a:t>
             </a:fld>
             <a:endParaRPr lang="en-US"/>
           </a:p>
@@ -1774,7 +1774,7 @@
           <a:p>
             <a:fld id="{5BCAD085-E8A6-8845-BD4E-CB4CCA059FC4}" type="datetimeFigureOut">
               <a:rPr lang="en-US" smtClean="0"/>
-              <a:t>5/16/2026</a:t>
+              <a:t>5/17/2026</a:t>
             </a:fld>
             <a:endParaRPr lang="en-US"/>
           </a:p>
@@ -1891,7 +1891,7 @@
           <a:p>
             <a:fld id="{5BCAD085-E8A6-8845-BD4E-CB4CCA059FC4}" type="datetimeFigureOut">
               <a:rPr lang="en-US" smtClean="0"/>
-              <a:t>5/16/2026</a:t>
+              <a:t>5/17/2026</a:t>
             </a:fld>
             <a:endParaRPr lang="en-US"/>
           </a:p>
@@ -1986,7 +1986,7 @@
           <a:p>
             <a:fld id="{5BCAD085-E8A6-8845-BD4E-CB4CCA059FC4}" type="datetimeFigureOut">
               <a:rPr lang="en-US" smtClean="0"/>
-              <a:t>5/16/2026</a:t>
+              <a:t>5/17/2026</a:t>
             </a:fld>
             <a:endParaRPr lang="en-US"/>
           </a:p>
@@ -2261,7 +2261,7 @@
           <a:p>
             <a:fld id="{5BCAD085-E8A6-8845-BD4E-CB4CCA059FC4}" type="datetimeFigureOut">
               <a:rPr lang="en-US" smtClean="0"/>
-              <a:t>5/16/2026</a:t>
+              <a:t>5/17/2026</a:t>
             </a:fld>
             <a:endParaRPr lang="en-US"/>
           </a:p>
@@ -2513,7 +2513,7 @@
           <a:p>
             <a:fld id="{5BCAD085-E8A6-8845-BD4E-CB4CCA059FC4}" type="datetimeFigureOut">
               <a:rPr lang="en-US" smtClean="0"/>
-              <a:t>5/16/2026</a:t>
+              <a:t>5/17/2026</a:t>
             </a:fld>
             <a:endParaRPr lang="en-US"/>
           </a:p>
@@ -2724,7 +2724,7 @@
           <a:p>
             <a:fld id="{5BCAD085-E8A6-8845-BD4E-CB4CCA059FC4}" type="datetimeFigureOut">
               <a:rPr lang="en-US" smtClean="0"/>
-              <a:t>5/16/2026</a:t>
+              <a:t>5/17/2026</a:t>
             </a:fld>
             <a:endParaRPr lang="en-US"/>
           </a:p>
@@ -3295,7 +3295,7 @@
         <p:spPr>
           <a:xfrm>
             <a:off x="1097280" y="4206240"/>
-            <a:ext cx="9601200" cy="640080"/>
+            <a:ext cx="9601200" cy="430887"/>
           </a:xfrm>
           <a:prstGeom prst="rect">
             <a:avLst/>
@@ -3316,58 +3316,100 @@
               </a:defRPr>
             </a:pPr>
             <a:r>
-              <a:rPr dirty="0" err="1"/>
+              <a:rPr dirty="0" err="1">
+                <a:latin typeface="Arial" panose="020B0604020202020204" pitchFamily="34" charset="0"/>
+                <a:cs typeface="Arial" panose="020B0604020202020204" pitchFamily="34" charset="0"/>
+              </a:rPr>
               <a:t>Giải</a:t>
             </a:r>
             <a:r>
-              <a:rPr dirty="0"/>
+              <a:rPr dirty="0">
+                <a:latin typeface="Arial" panose="020B0604020202020204" pitchFamily="34" charset="0"/>
+                <a:cs typeface="Arial" panose="020B0604020202020204" pitchFamily="34" charset="0"/>
+              </a:rPr>
               <a:t> </a:t>
             </a:r>
             <a:r>
-              <a:rPr dirty="0" err="1"/>
+              <a:rPr dirty="0" err="1">
+                <a:latin typeface="Arial" panose="020B0604020202020204" pitchFamily="34" charset="0"/>
+                <a:cs typeface="Arial" panose="020B0604020202020204" pitchFamily="34" charset="0"/>
+              </a:rPr>
               <a:t>pháp</a:t>
             </a:r>
             <a:r>
-              <a:rPr dirty="0"/>
+              <a:rPr dirty="0">
+                <a:latin typeface="Arial" panose="020B0604020202020204" pitchFamily="34" charset="0"/>
+                <a:cs typeface="Arial" panose="020B0604020202020204" pitchFamily="34" charset="0"/>
+              </a:rPr>
               <a:t> </a:t>
             </a:r>
             <a:r>
-              <a:rPr dirty="0" err="1"/>
+              <a:rPr dirty="0" err="1">
+                <a:latin typeface="Arial" panose="020B0604020202020204" pitchFamily="34" charset="0"/>
+                <a:cs typeface="Arial" panose="020B0604020202020204" pitchFamily="34" charset="0"/>
+              </a:rPr>
               <a:t>ứng</a:t>
             </a:r>
             <a:r>
-              <a:rPr dirty="0"/>
+              <a:rPr dirty="0">
+                <a:latin typeface="Arial" panose="020B0604020202020204" pitchFamily="34" charset="0"/>
+                <a:cs typeface="Arial" panose="020B0604020202020204" pitchFamily="34" charset="0"/>
+              </a:rPr>
               <a:t> </a:t>
             </a:r>
             <a:r>
-              <a:rPr dirty="0" err="1"/>
+              <a:rPr dirty="0" err="1">
+                <a:latin typeface="Arial" panose="020B0604020202020204" pitchFamily="34" charset="0"/>
+                <a:cs typeface="Arial" panose="020B0604020202020204" pitchFamily="34" charset="0"/>
+              </a:rPr>
               <a:t>phó</a:t>
             </a:r>
             <a:r>
-              <a:rPr dirty="0"/>
+              <a:rPr dirty="0">
+                <a:latin typeface="Arial" panose="020B0604020202020204" pitchFamily="34" charset="0"/>
+                <a:cs typeface="Arial" panose="020B0604020202020204" pitchFamily="34" charset="0"/>
+              </a:rPr>
               <a:t> </a:t>
             </a:r>
             <a:r>
-              <a:rPr dirty="0" err="1"/>
+              <a:rPr dirty="0" err="1">
+                <a:latin typeface="Arial" panose="020B0604020202020204" pitchFamily="34" charset="0"/>
+                <a:cs typeface="Arial" panose="020B0604020202020204" pitchFamily="34" charset="0"/>
+              </a:rPr>
               <a:t>của</a:t>
             </a:r>
             <a:r>
-              <a:rPr dirty="0"/>
+              <a:rPr dirty="0">
+                <a:latin typeface="Arial" panose="020B0604020202020204" pitchFamily="34" charset="0"/>
+                <a:cs typeface="Arial" panose="020B0604020202020204" pitchFamily="34" charset="0"/>
+              </a:rPr>
               <a:t> </a:t>
             </a:r>
             <a:r>
-              <a:rPr dirty="0" err="1"/>
+              <a:rPr dirty="0" err="1">
+                <a:latin typeface="Arial" panose="020B0604020202020204" pitchFamily="34" charset="0"/>
+                <a:cs typeface="Arial" panose="020B0604020202020204" pitchFamily="34" charset="0"/>
+              </a:rPr>
               <a:t>doanh</a:t>
             </a:r>
             <a:r>
-              <a:rPr dirty="0"/>
+              <a:rPr dirty="0">
+                <a:latin typeface="Arial" panose="020B0604020202020204" pitchFamily="34" charset="0"/>
+                <a:cs typeface="Arial" panose="020B0604020202020204" pitchFamily="34" charset="0"/>
+              </a:rPr>
               <a:t> </a:t>
             </a:r>
             <a:r>
-              <a:rPr dirty="0" err="1"/>
+              <a:rPr dirty="0" err="1">
+                <a:latin typeface="Arial" panose="020B0604020202020204" pitchFamily="34" charset="0"/>
+                <a:cs typeface="Arial" panose="020B0604020202020204" pitchFamily="34" charset="0"/>
+              </a:rPr>
               <a:t>nghiệp</a:t>
             </a:r>
-            <a:endParaRPr dirty="0"/>
+            <a:endParaRPr dirty="0">
+              <a:latin typeface="Arial" panose="020B0604020202020204" pitchFamily="34" charset="0"/>
+              <a:cs typeface="Arial" panose="020B0604020202020204" pitchFamily="34" charset="0"/>
+            </a:endParaRPr>
           </a:p>
         </p:txBody>
       </p:sp>
@@ -3455,214 +3497,6 @@
             <a:r>
               <a:rPr dirty="0"/>
               <a:t> Học</a:t>
-            </a:r>
-          </a:p>
-        </p:txBody>
-      </p:sp>
-      <p:sp>
-        <p:nvSpPr>
-          <p:cNvPr id="9" name="Oval 8"/>
-          <p:cNvSpPr/>
-          <p:nvPr/>
-        </p:nvSpPr>
-        <p:spPr>
-          <a:xfrm>
-            <a:off x="8584163" y="5029200"/>
-            <a:ext cx="696997" cy="594360"/>
-          </a:xfrm>
-          <a:prstGeom prst="ellipse">
-            <a:avLst/>
-          </a:prstGeom>
-          <a:solidFill>
-            <a:srgbClr val="D4A017"/>
-          </a:solidFill>
-          <a:ln>
-            <a:noFill/>
-          </a:ln>
-        </p:spPr>
-        <p:style>
-          <a:lnRef idx="1">
-            <a:schemeClr val="accent1"/>
-          </a:lnRef>
-          <a:fillRef idx="3">
-            <a:schemeClr val="accent1"/>
-          </a:fillRef>
-          <a:effectRef idx="2">
-            <a:schemeClr val="accent1"/>
-          </a:effectRef>
-          <a:fontRef idx="minor">
-            <a:schemeClr val="lt1"/>
-          </a:fontRef>
-        </p:style>
-        <p:txBody>
-          <a:bodyPr rtlCol="0" anchor="ctr"/>
-          <a:lstStyle/>
-          <a:p>
-            <a:pPr algn="ctr">
-              <a:defRPr sz="1800">
-                <a:solidFill>
-                  <a:srgbClr val="FFFFFF"/>
-                </a:solidFill>
-              </a:defRPr>
-            </a:pPr>
-            <a:r>
-              <a:t>Au</a:t>
-            </a:r>
-          </a:p>
-        </p:txBody>
-      </p:sp>
-      <p:sp>
-        <p:nvSpPr>
-          <p:cNvPr id="10" name="Oval 9"/>
-          <p:cNvSpPr/>
-          <p:nvPr/>
-        </p:nvSpPr>
-        <p:spPr>
-          <a:xfrm>
-            <a:off x="9418320" y="5029200"/>
-            <a:ext cx="594360" cy="594360"/>
-          </a:xfrm>
-          <a:prstGeom prst="ellipse">
-            <a:avLst/>
-          </a:prstGeom>
-          <a:solidFill>
-            <a:srgbClr val="E86C00"/>
-          </a:solidFill>
-          <a:ln>
-            <a:noFill/>
-          </a:ln>
-        </p:spPr>
-        <p:style>
-          <a:lnRef idx="1">
-            <a:schemeClr val="accent1"/>
-          </a:lnRef>
-          <a:fillRef idx="3">
-            <a:schemeClr val="accent1"/>
-          </a:fillRef>
-          <a:effectRef idx="2">
-            <a:schemeClr val="accent1"/>
-          </a:effectRef>
-          <a:fontRef idx="minor">
-            <a:schemeClr val="lt1"/>
-          </a:fontRef>
-        </p:style>
-        <p:txBody>
-          <a:bodyPr rtlCol="0" anchor="ctr"/>
-          <a:lstStyle/>
-          <a:p>
-            <a:pPr algn="ctr">
-              <a:defRPr sz="1800">
-                <a:solidFill>
-                  <a:srgbClr val="FFFFFF"/>
-                </a:solidFill>
-              </a:defRPr>
-            </a:pPr>
-            <a:r>
-              <a:t>⛽</a:t>
-            </a:r>
-          </a:p>
-        </p:txBody>
-      </p:sp>
-      <p:sp>
-        <p:nvSpPr>
-          <p:cNvPr id="11" name="Oval 10"/>
-          <p:cNvSpPr/>
-          <p:nvPr/>
-        </p:nvSpPr>
-        <p:spPr>
-          <a:xfrm>
-            <a:off x="10149840" y="5029200"/>
-            <a:ext cx="594360" cy="594360"/>
-          </a:xfrm>
-          <a:prstGeom prst="ellipse">
-            <a:avLst/>
-          </a:prstGeom>
-          <a:solidFill>
-            <a:srgbClr val="C0392B"/>
-          </a:solidFill>
-          <a:ln>
-            <a:noFill/>
-          </a:ln>
-        </p:spPr>
-        <p:style>
-          <a:lnRef idx="1">
-            <a:schemeClr val="accent1"/>
-          </a:lnRef>
-          <a:fillRef idx="3">
-            <a:schemeClr val="accent1"/>
-          </a:fillRef>
-          <a:effectRef idx="2">
-            <a:schemeClr val="accent1"/>
-          </a:effectRef>
-          <a:fontRef idx="minor">
-            <a:schemeClr val="lt1"/>
-          </a:fontRef>
-        </p:style>
-        <p:txBody>
-          <a:bodyPr rtlCol="0" anchor="ctr"/>
-          <a:lstStyle/>
-          <a:p>
-            <a:pPr algn="ctr">
-              <a:defRPr sz="1800">
-                <a:solidFill>
-                  <a:srgbClr val="FFFFFF"/>
-                </a:solidFill>
-              </a:defRPr>
-            </a:pPr>
-            <a:r>
-              <a:t>%</a:t>
-            </a:r>
-          </a:p>
-        </p:txBody>
-      </p:sp>
-      <p:sp>
-        <p:nvSpPr>
-          <p:cNvPr id="12" name="Oval 11"/>
-          <p:cNvSpPr/>
-          <p:nvPr/>
-        </p:nvSpPr>
-        <p:spPr>
-          <a:xfrm>
-            <a:off x="10881360" y="5029200"/>
-            <a:ext cx="594360" cy="594360"/>
-          </a:xfrm>
-          <a:prstGeom prst="ellipse">
-            <a:avLst/>
-          </a:prstGeom>
-          <a:solidFill>
-            <a:srgbClr val="1B8A4B"/>
-          </a:solidFill>
-          <a:ln>
-            <a:noFill/>
-          </a:ln>
-        </p:spPr>
-        <p:style>
-          <a:lnRef idx="1">
-            <a:schemeClr val="accent1"/>
-          </a:lnRef>
-          <a:fillRef idx="3">
-            <a:schemeClr val="accent1"/>
-          </a:fillRef>
-          <a:effectRef idx="2">
-            <a:schemeClr val="accent1"/>
-          </a:effectRef>
-          <a:fontRef idx="minor">
-            <a:schemeClr val="lt1"/>
-          </a:fontRef>
-        </p:style>
-        <p:txBody>
-          <a:bodyPr rtlCol="0" anchor="ctr"/>
-          <a:lstStyle/>
-          <a:p>
-            <a:pPr algn="ctr">
-              <a:defRPr sz="1800">
-                <a:solidFill>
-                  <a:srgbClr val="FFFFFF"/>
-                </a:solidFill>
-              </a:defRPr>
-            </a:pPr>
-            <a:r>
-              <a:t>📊</a:t>
             </a:r>
           </a:p>
         </p:txBody>
@@ -3702,50 +3536,6 @@
       </p:grpSpPr>
       <p:sp>
         <p:nvSpPr>
-          <p:cNvPr id="2" name="Rectangle 1"/>
-          <p:cNvSpPr/>
-          <p:nvPr/>
-        </p:nvSpPr>
-        <p:spPr>
-          <a:xfrm>
-            <a:off x="0" y="0"/>
-            <a:ext cx="12191695" cy="73152"/>
-          </a:xfrm>
-          <a:prstGeom prst="rect">
-            <a:avLst/>
-          </a:prstGeom>
-          <a:solidFill>
-            <a:srgbClr val="2E86AB"/>
-          </a:solidFill>
-          <a:ln>
-            <a:noFill/>
-          </a:ln>
-        </p:spPr>
-        <p:style>
-          <a:lnRef idx="1">
-            <a:schemeClr val="accent1"/>
-          </a:lnRef>
-          <a:fillRef idx="3">
-            <a:schemeClr val="accent1"/>
-          </a:fillRef>
-          <a:effectRef idx="2">
-            <a:schemeClr val="accent1"/>
-          </a:effectRef>
-          <a:fontRef idx="minor">
-            <a:schemeClr val="lt1"/>
-          </a:fontRef>
-        </p:style>
-        <p:txBody>
-          <a:bodyPr rtlCol="0" anchor="ctr"/>
-          <a:lstStyle/>
-          <a:p>
-            <a:pPr algn="ctr"/>
-            <a:endParaRPr/>
-          </a:p>
-        </p:txBody>
-      </p:sp>
-      <p:sp>
-        <p:nvSpPr>
           <p:cNvPr id="3" name="TextBox 2"/>
           <p:cNvSpPr txBox="1"/>
           <p:nvPr/>
@@ -4439,85 +4229,6 @@
             </a:pPr>
             <a:r>
               <a:t>Đầu tư &amp; định vị chiến lược</a:t>
-            </a:r>
-          </a:p>
-        </p:txBody>
-      </p:sp>
-      <p:sp>
-        <p:nvSpPr>
-          <p:cNvPr id="20" name="Rectangle 19"/>
-          <p:cNvSpPr/>
-          <p:nvPr/>
-        </p:nvSpPr>
-        <p:spPr>
-          <a:xfrm>
-            <a:off x="2743200" y="5760720"/>
-            <a:ext cx="6400800" cy="22860"/>
-          </a:xfrm>
-          <a:prstGeom prst="rect">
-            <a:avLst/>
-          </a:prstGeom>
-          <a:solidFill>
-            <a:srgbClr val="2E86AB"/>
-          </a:solidFill>
-          <a:ln>
-            <a:noFill/>
-          </a:ln>
-        </p:spPr>
-        <p:style>
-          <a:lnRef idx="1">
-            <a:schemeClr val="accent1"/>
-          </a:lnRef>
-          <a:fillRef idx="3">
-            <a:schemeClr val="accent1"/>
-          </a:fillRef>
-          <a:effectRef idx="2">
-            <a:schemeClr val="accent1"/>
-          </a:effectRef>
-          <a:fontRef idx="minor">
-            <a:schemeClr val="lt1"/>
-          </a:fontRef>
-        </p:style>
-        <p:txBody>
-          <a:bodyPr rtlCol="0" anchor="ctr"/>
-          <a:lstStyle/>
-          <a:p>
-            <a:pPr algn="ctr"/>
-            <a:endParaRPr/>
-          </a:p>
-        </p:txBody>
-      </p:sp>
-      <p:sp>
-        <p:nvSpPr>
-          <p:cNvPr id="21" name="TextBox 20"/>
-          <p:cNvSpPr txBox="1"/>
-          <p:nvPr/>
-        </p:nvSpPr>
-        <p:spPr>
-          <a:xfrm>
-            <a:off x="914400" y="5943600"/>
-            <a:ext cx="10058400" cy="640080"/>
-          </a:xfrm>
-          <a:prstGeom prst="rect">
-            <a:avLst/>
-          </a:prstGeom>
-          <a:noFill/>
-        </p:spPr>
-        <p:txBody>
-          <a:bodyPr wrap="square">
-            <a:spAutoFit/>
-          </a:bodyPr>
-          <a:lstStyle/>
-          <a:p>
-            <a:pPr algn="ctr">
-              <a:defRPr sz="2000" b="0">
-                <a:solidFill>
-                  <a:srgbClr val="2E86AB"/>
-                </a:solidFill>
-              </a:defRPr>
-            </a:pPr>
-            <a:r>
-              <a:t>Cảm ơn quý thầy/cô và các anh chị đã lắng nghe!</a:t>
             </a:r>
           </a:p>
         </p:txBody>
@@ -5035,15 +4746,74 @@
               </a:defRPr>
             </a:pPr>
             <a:r>
-              <a:t>Dựng mô hình 3D / BIM</a:t>
-            </a:r>
-            <a:br/>
-            <a:r>
-              <a:t>Đội ngũ Gen Z năng động</a:t>
-            </a:r>
-            <a:br/>
-            <a:r>
-              <a:t>Chi phí VND</a:t>
+              <a:rPr dirty="0" err="1"/>
+              <a:t>Dựng</a:t>
+            </a:r>
+            <a:r>
+              <a:rPr dirty="0"/>
+              <a:t> </a:t>
+            </a:r>
+            <a:r>
+              <a:rPr dirty="0" err="1"/>
+              <a:t>mô</a:t>
+            </a:r>
+            <a:r>
+              <a:rPr dirty="0"/>
+              <a:t> </a:t>
+            </a:r>
+            <a:r>
+              <a:rPr dirty="0" err="1"/>
+              <a:t>hình</a:t>
+            </a:r>
+            <a:r>
+              <a:rPr dirty="0"/>
+              <a:t> 3D / BIM</a:t>
+            </a:r>
+            <a:br>
+              <a:rPr dirty="0"/>
+            </a:br>
+            <a:r>
+              <a:rPr dirty="0" err="1"/>
+              <a:t>Đội</a:t>
+            </a:r>
+            <a:r>
+              <a:rPr dirty="0"/>
+              <a:t> </a:t>
+            </a:r>
+            <a:r>
+              <a:rPr dirty="0" err="1"/>
+              <a:t>ngũ</a:t>
+            </a:r>
+            <a:r>
+              <a:rPr dirty="0"/>
+              <a:t> Gen Z </a:t>
+            </a:r>
+            <a:r>
+              <a:rPr dirty="0" err="1"/>
+              <a:t>năng</a:t>
+            </a:r>
+            <a:r>
+              <a:rPr dirty="0"/>
+              <a:t> </a:t>
+            </a:r>
+            <a:r>
+              <a:rPr dirty="0" err="1"/>
+              <a:t>động</a:t>
+            </a:r>
+            <a:br>
+              <a:rPr dirty="0"/>
+            </a:br>
+            <a:r>
+              <a:rPr dirty="0"/>
+              <a:t>Chi </a:t>
+            </a:r>
+            <a:r>
+              <a:rPr dirty="0" err="1"/>
+              <a:t>phí</a:t>
+            </a:r>
+            <a:r>
+              <a:rPr dirty="0"/>
+              <a:t> VND</a:t>
             </a:r>
           </a:p>
         </p:txBody>
@@ -5234,7 +5004,7 @@
         <p:spPr>
           <a:xfrm>
             <a:off x="8595360" y="2834640"/>
-            <a:ext cx="2560320" cy="640080"/>
+            <a:ext cx="2560320" cy="600164"/>
           </a:xfrm>
           <a:prstGeom prst="rect">
             <a:avLst/>
@@ -5255,16 +5025,116 @@
               </a:defRPr>
             </a:pPr>
             <a:r>
-              <a:t>Mô hình 3D chất lượng cao</a:t>
-            </a:r>
-            <a:br/>
-            <a:r>
-              <a:t>Đúng tiến độ quốc tế</a:t>
-            </a:r>
-            <a:br/>
-            <a:r>
-              <a:t>Phục vụ ngành xây dựng</a:t>
-            </a:r>
+              <a:rPr dirty="0" err="1"/>
+              <a:t>Mô</a:t>
+            </a:r>
+            <a:r>
+              <a:rPr dirty="0"/>
+              <a:t> </a:t>
+            </a:r>
+            <a:r>
+              <a:rPr dirty="0" err="1"/>
+              <a:t>hình</a:t>
+            </a:r>
+            <a:r>
+              <a:rPr dirty="0"/>
+              <a:t> 3D </a:t>
+            </a:r>
+            <a:r>
+              <a:rPr dirty="0" err="1"/>
+              <a:t>chất</a:t>
+            </a:r>
+            <a:r>
+              <a:rPr dirty="0"/>
+              <a:t> </a:t>
+            </a:r>
+            <a:r>
+              <a:rPr dirty="0" err="1"/>
+              <a:t>lượng</a:t>
+            </a:r>
+            <a:r>
+              <a:rPr dirty="0"/>
+              <a:t> </a:t>
+            </a:r>
+            <a:r>
+              <a:rPr dirty="0" err="1"/>
+              <a:t>cao</a:t>
+            </a:r>
+            <a:br>
+              <a:rPr dirty="0"/>
+            </a:br>
+            <a:r>
+              <a:rPr dirty="0" err="1"/>
+              <a:t>Đúng</a:t>
+            </a:r>
+            <a:r>
+              <a:rPr dirty="0"/>
+              <a:t> </a:t>
+            </a:r>
+            <a:r>
+              <a:rPr lang="en-US" dirty="0" err="1"/>
+              <a:t>tiêu</a:t>
+            </a:r>
+            <a:r>
+              <a:rPr lang="en-US" dirty="0"/>
+              <a:t> </a:t>
+            </a:r>
+            <a:r>
+              <a:rPr lang="en-US" dirty="0" err="1"/>
+              <a:t>chuẩn</a:t>
+            </a:r>
+            <a:r>
+              <a:rPr lang="en-US" dirty="0"/>
+              <a:t> </a:t>
+            </a:r>
+            <a:r>
+              <a:rPr dirty="0" err="1"/>
+              <a:t>quốc</a:t>
+            </a:r>
+            <a:r>
+              <a:rPr dirty="0"/>
+              <a:t> </a:t>
+            </a:r>
+            <a:r>
+              <a:rPr dirty="0" err="1"/>
+              <a:t>tế</a:t>
+            </a:r>
+            <a:br>
+              <a:rPr dirty="0"/>
+            </a:br>
+            <a:r>
+              <a:rPr dirty="0"/>
+              <a:t>Phục </a:t>
+            </a:r>
+            <a:r>
+              <a:rPr dirty="0" err="1"/>
+              <a:t>vụ</a:t>
+            </a:r>
+            <a:r>
+              <a:rPr dirty="0"/>
+              <a:t> </a:t>
+            </a:r>
+            <a:r>
+              <a:rPr dirty="0" err="1"/>
+              <a:t>ngành</a:t>
+            </a:r>
+            <a:r>
+              <a:rPr dirty="0"/>
+              <a:t> </a:t>
+            </a:r>
+            <a:r>
+              <a:rPr dirty="0" err="1"/>
+              <a:t>xây</a:t>
+            </a:r>
+            <a:r>
+              <a:rPr dirty="0"/>
+              <a:t> </a:t>
+            </a:r>
+            <a:r>
+              <a:rPr dirty="0" err="1"/>
+              <a:t>dựng</a:t>
+            </a:r>
+            <a:endParaRPr dirty="0"/>
           </a:p>
         </p:txBody>
       </p:sp>
@@ -5894,7 +5764,7 @@
         <p:spPr>
           <a:xfrm>
             <a:off x="731520" y="137160"/>
-            <a:ext cx="10058400" cy="822960"/>
+            <a:ext cx="10058400" cy="492443"/>
           </a:xfrm>
           <a:prstGeom prst="rect">
             <a:avLst/>
@@ -5916,7 +5786,7 @@
             </a:pPr>
             <a:r>
               <a:rPr dirty="0"/>
-              <a:t>TỔNG QUAN CÁC YẾU TỐ VĨ MÔ ẢNH HƯỞNG</a:t>
+              <a:t>TỔNG QUAN CÁC YẾU TỐ ẢNH HƯỞNG</a:t>
             </a:r>
           </a:p>
         </p:txBody>
@@ -7221,7 +7091,7 @@
         </p:nvSpPr>
         <p:spPr>
           <a:xfrm>
-            <a:off x="548640" y="1463040"/>
+            <a:off x="548640" y="2651760"/>
             <a:ext cx="5303520" cy="2377440"/>
           </a:xfrm>
           <a:prstGeom prst="roundRect">
@@ -7267,7 +7137,7 @@
         </p:nvSpPr>
         <p:spPr>
           <a:xfrm>
-            <a:off x="822960" y="1554480"/>
+            <a:off x="822960" y="2743200"/>
             <a:ext cx="4754880" cy="365760"/>
           </a:xfrm>
           <a:prstGeom prst="rect">
@@ -7302,7 +7172,7 @@
         </p:nvSpPr>
         <p:spPr>
           <a:xfrm>
-            <a:off x="1371600" y="2103120"/>
+            <a:off x="1371600" y="3291840"/>
             <a:ext cx="822960" cy="822960"/>
           </a:xfrm>
           <a:prstGeom prst="ellipse">
@@ -7354,7 +7224,7 @@
         </p:nvSpPr>
         <p:spPr>
           <a:xfrm>
-            <a:off x="1188720" y="2971800"/>
+            <a:off x="1188720" y="4160520"/>
             <a:ext cx="1188720" cy="274320"/>
           </a:xfrm>
           <a:prstGeom prst="rect">
@@ -7389,7 +7259,7 @@
         </p:nvSpPr>
         <p:spPr>
           <a:xfrm>
-            <a:off x="2468880" y="2286000"/>
+            <a:off x="2468880" y="3474720"/>
             <a:ext cx="1097280" cy="457200"/>
           </a:xfrm>
           <a:prstGeom prst="leftRightArrow">
@@ -7433,7 +7303,7 @@
         </p:nvSpPr>
         <p:spPr>
           <a:xfrm>
-            <a:off x="3840480" y="2103120"/>
+            <a:off x="3840480" y="3291840"/>
             <a:ext cx="822960" cy="822960"/>
           </a:xfrm>
           <a:prstGeom prst="ellipse">
@@ -7485,7 +7355,7 @@
         </p:nvSpPr>
         <p:spPr>
           <a:xfrm>
-            <a:off x="3657600" y="2971800"/>
+            <a:off x="3657600" y="4160520"/>
             <a:ext cx="1188720" cy="274320"/>
           </a:xfrm>
           <a:prstGeom prst="rect">
@@ -7520,7 +7390,7 @@
         </p:nvSpPr>
         <p:spPr>
           <a:xfrm>
-            <a:off x="822960" y="3337560"/>
+            <a:off x="1463040" y="4520005"/>
             <a:ext cx="4754880" cy="261610"/>
           </a:xfrm>
           <a:prstGeom prst="rect">
@@ -7587,7 +7457,15 @@
             </a:r>
             <a:r>
               <a:rPr dirty="0"/>
-              <a:t> — </a:t>
+              <a:t> </a:t>
+            </a:r>
+            <a:r>
+              <a:rPr lang="en-US" dirty="0"/>
+              <a:t>-</a:t>
+            </a:r>
+            <a:r>
+              <a:rPr dirty="0"/>
+              <a:t> </a:t>
             </a:r>
             <a:r>
               <a:rPr dirty="0" err="1"/>
@@ -7637,7 +7515,7 @@
         </p:nvSpPr>
         <p:spPr>
           <a:xfrm>
-            <a:off x="6217920" y="1463040"/>
+            <a:off x="6217920" y="2651760"/>
             <a:ext cx="5486400" cy="2377440"/>
           </a:xfrm>
           <a:prstGeom prst="roundRect">
@@ -7683,7 +7561,7 @@
         </p:nvSpPr>
         <p:spPr>
           <a:xfrm>
-            <a:off x="6492240" y="1554480"/>
+            <a:off x="6492240" y="2743200"/>
             <a:ext cx="4937760" cy="365760"/>
           </a:xfrm>
           <a:prstGeom prst="rect">
@@ -7718,7 +7596,7 @@
         </p:nvSpPr>
         <p:spPr>
           <a:xfrm>
-            <a:off x="6492240" y="2011680"/>
+            <a:off x="6492240" y="3200400"/>
             <a:ext cx="2286000" cy="1463040"/>
           </a:xfrm>
           <a:prstGeom prst="roundRect">
@@ -7762,7 +7640,7 @@
         </p:nvSpPr>
         <p:spPr>
           <a:xfrm>
-            <a:off x="6583680" y="2057400"/>
+            <a:off x="6583680" y="3246120"/>
             <a:ext cx="2103120" cy="365760"/>
           </a:xfrm>
           <a:prstGeom prst="rect">
@@ -7797,7 +7675,7 @@
         </p:nvSpPr>
         <p:spPr>
           <a:xfrm>
-            <a:off x="6583680" y="2468880"/>
+            <a:off x="6583680" y="3657600"/>
             <a:ext cx="2103120" cy="914400"/>
           </a:xfrm>
           <a:prstGeom prst="rect">
@@ -7819,16 +7697,88 @@
               </a:defRPr>
             </a:pPr>
             <a:r>
-              <a:t>Doanh thu quy VND tăng</a:t>
-            </a:r>
-            <a:br/>
-            <a:r>
-              <a:t>→ Thuận lợi cho</a:t>
-            </a:r>
-            <a:br/>
-            <a:r>
-              <a:t>báo cáo tài chính</a:t>
-            </a:r>
+              <a:rPr dirty="0"/>
+              <a:t>Doanh </a:t>
+            </a:r>
+            <a:r>
+              <a:rPr dirty="0" err="1"/>
+              <a:t>thu</a:t>
+            </a:r>
+            <a:r>
+              <a:rPr dirty="0"/>
+              <a:t> </a:t>
+            </a:r>
+            <a:r>
+              <a:rPr dirty="0" err="1"/>
+              <a:t>quy</a:t>
+            </a:r>
+            <a:r>
+              <a:rPr dirty="0"/>
+              <a:t> VND </a:t>
+            </a:r>
+            <a:r>
+              <a:rPr dirty="0" err="1"/>
+              <a:t>tăng</a:t>
+            </a:r>
+            <a:br>
+              <a:rPr dirty="0"/>
+            </a:br>
+            <a:r>
+              <a:rPr dirty="0"/>
+              <a:t>→ </a:t>
+            </a:r>
+            <a:r>
+              <a:rPr dirty="0" err="1"/>
+              <a:t>Thuận</a:t>
+            </a:r>
+            <a:r>
+              <a:rPr dirty="0"/>
+              <a:t> </a:t>
+            </a:r>
+            <a:r>
+              <a:rPr dirty="0" err="1"/>
+              <a:t>lợi</a:t>
+            </a:r>
+            <a:r>
+              <a:rPr dirty="0"/>
+              <a:t> </a:t>
+            </a:r>
+            <a:r>
+              <a:rPr dirty="0" err="1"/>
+              <a:t>cho</a:t>
+            </a:r>
+            <a:br>
+              <a:rPr dirty="0"/>
+            </a:br>
+            <a:r>
+              <a:rPr dirty="0" err="1"/>
+              <a:t>báo</a:t>
+            </a:r>
+            <a:r>
+              <a:rPr dirty="0"/>
+              <a:t> </a:t>
+            </a:r>
+            <a:r>
+              <a:rPr dirty="0" err="1"/>
+              <a:t>cáo</a:t>
+            </a:r>
+            <a:r>
+              <a:rPr dirty="0"/>
+              <a:t> </a:t>
+            </a:r>
+            <a:r>
+              <a:rPr dirty="0" err="1"/>
+              <a:t>tài</a:t>
+            </a:r>
+            <a:r>
+              <a:rPr dirty="0"/>
+              <a:t> </a:t>
+            </a:r>
+            <a:r>
+              <a:rPr dirty="0" err="1"/>
+              <a:t>chính</a:t>
+            </a:r>
+            <a:endParaRPr dirty="0"/>
           </a:p>
         </p:txBody>
       </p:sp>
@@ -7840,7 +7790,7 @@
         </p:nvSpPr>
         <p:spPr>
           <a:xfrm>
-            <a:off x="9144000" y="2011680"/>
+            <a:off x="9144000" y="3200400"/>
             <a:ext cx="2286000" cy="1463040"/>
           </a:xfrm>
           <a:prstGeom prst="roundRect">
@@ -7884,7 +7834,7 @@
         </p:nvSpPr>
         <p:spPr>
           <a:xfrm>
-            <a:off x="9235440" y="2057400"/>
+            <a:off x="9235440" y="3246120"/>
             <a:ext cx="2103120" cy="365760"/>
           </a:xfrm>
           <a:prstGeom prst="rect">
@@ -7919,7 +7869,7 @@
         </p:nvSpPr>
         <p:spPr>
           <a:xfrm>
-            <a:off x="9235440" y="2468880"/>
+            <a:off x="9235440" y="3657600"/>
             <a:ext cx="2103120" cy="914400"/>
           </a:xfrm>
           <a:prstGeom prst="rect">
@@ -7950,648 +7900,6 @@
             <a:br/>
             <a:r>
               <a:t>rủi ro tỷ giá</a:t>
-            </a:r>
-          </a:p>
-        </p:txBody>
-      </p:sp>
-      <p:sp>
-        <p:nvSpPr>
-          <p:cNvPr id="21" name="Rounded Rectangle 20"/>
-          <p:cNvSpPr/>
-          <p:nvPr/>
-        </p:nvSpPr>
-        <p:spPr>
-          <a:xfrm>
-            <a:off x="548640" y="4206240"/>
-            <a:ext cx="11064240" cy="2286000"/>
-          </a:xfrm>
-          <a:prstGeom prst="roundRect">
-            <a:avLst/>
-          </a:prstGeom>
-          <a:solidFill>
-            <a:srgbClr val="FFFFFF"/>
-          </a:solidFill>
-          <a:ln w="19050">
-            <a:solidFill>
-              <a:srgbClr val="2E86AB"/>
-            </a:solidFill>
-          </a:ln>
-        </p:spPr>
-        <p:style>
-          <a:lnRef idx="1">
-            <a:schemeClr val="accent1"/>
-          </a:lnRef>
-          <a:fillRef idx="3">
-            <a:schemeClr val="accent1"/>
-          </a:fillRef>
-          <a:effectRef idx="2">
-            <a:schemeClr val="accent1"/>
-          </a:effectRef>
-          <a:fontRef idx="minor">
-            <a:schemeClr val="lt1"/>
-          </a:fontRef>
-        </p:style>
-        <p:txBody>
-          <a:bodyPr rtlCol="0" anchor="ctr"/>
-          <a:lstStyle/>
-          <a:p>
-            <a:pPr algn="ctr"/>
-            <a:endParaRPr/>
-          </a:p>
-        </p:txBody>
-      </p:sp>
-      <p:sp>
-        <p:nvSpPr>
-          <p:cNvPr id="22" name="TextBox 21"/>
-          <p:cNvSpPr txBox="1"/>
-          <p:nvPr/>
-        </p:nvSpPr>
-        <p:spPr>
-          <a:xfrm>
-            <a:off x="822960" y="4297680"/>
-            <a:ext cx="10515600" cy="365760"/>
-          </a:xfrm>
-          <a:prstGeom prst="rect">
-            <a:avLst/>
-          </a:prstGeom>
-          <a:noFill/>
-        </p:spPr>
-        <p:txBody>
-          <a:bodyPr wrap="square">
-            <a:spAutoFit/>
-          </a:bodyPr>
-          <a:lstStyle/>
-          <a:p>
-            <a:pPr algn="l">
-              <a:defRPr sz="1500" b="1">
-                <a:solidFill>
-                  <a:srgbClr val="1B3A5C"/>
-                </a:solidFill>
-              </a:defRPr>
-            </a:pPr>
-            <a:r>
-              <a:t>💡 VÍ DỤ MINH HỌA — Quản trị rủi ro tỷ giá (Financial Risk Management)</a:t>
-            </a:r>
-          </a:p>
-        </p:txBody>
-      </p:sp>
-      <p:sp>
-        <p:nvSpPr>
-          <p:cNvPr id="23" name="Rounded Rectangle 22"/>
-          <p:cNvSpPr/>
-          <p:nvPr/>
-        </p:nvSpPr>
-        <p:spPr>
-          <a:xfrm>
-            <a:off x="822960" y="4800600"/>
-            <a:ext cx="2377440" cy="1371600"/>
-          </a:xfrm>
-          <a:prstGeom prst="roundRect">
-            <a:avLst/>
-          </a:prstGeom>
-          <a:solidFill>
-            <a:srgbClr val="E8F4F8"/>
-          </a:solidFill>
-          <a:ln>
-            <a:noFill/>
-          </a:ln>
-        </p:spPr>
-        <p:style>
-          <a:lnRef idx="1">
-            <a:schemeClr val="accent1"/>
-          </a:lnRef>
-          <a:fillRef idx="3">
-            <a:schemeClr val="accent1"/>
-          </a:fillRef>
-          <a:effectRef idx="2">
-            <a:schemeClr val="accent1"/>
-          </a:effectRef>
-          <a:fontRef idx="minor">
-            <a:schemeClr val="lt1"/>
-          </a:fontRef>
-        </p:style>
-        <p:txBody>
-          <a:bodyPr rtlCol="0" anchor="ctr"/>
-          <a:lstStyle/>
-          <a:p>
-            <a:pPr algn="ctr"/>
-            <a:endParaRPr/>
-          </a:p>
-        </p:txBody>
-      </p:sp>
-      <p:sp>
-        <p:nvSpPr>
-          <p:cNvPr id="24" name="TextBox 23"/>
-          <p:cNvSpPr txBox="1"/>
-          <p:nvPr/>
-        </p:nvSpPr>
-        <p:spPr>
-          <a:xfrm>
-            <a:off x="914400" y="4846320"/>
-            <a:ext cx="2194560" cy="320040"/>
-          </a:xfrm>
-          <a:prstGeom prst="rect">
-            <a:avLst/>
-          </a:prstGeom>
-          <a:noFill/>
-        </p:spPr>
-        <p:txBody>
-          <a:bodyPr wrap="square">
-            <a:spAutoFit/>
-          </a:bodyPr>
-          <a:lstStyle/>
-          <a:p>
-            <a:pPr algn="ctr">
-              <a:defRPr sz="1100" b="1">
-                <a:solidFill>
-                  <a:srgbClr val="7F8C8D"/>
-                </a:solidFill>
-              </a:defRPr>
-            </a:pPr>
-            <a:r>
-              <a:t>Hợp đồng tháng</a:t>
-            </a:r>
-          </a:p>
-        </p:txBody>
-      </p:sp>
-      <p:sp>
-        <p:nvSpPr>
-          <p:cNvPr id="25" name="TextBox 24"/>
-          <p:cNvSpPr txBox="1"/>
-          <p:nvPr/>
-        </p:nvSpPr>
-        <p:spPr>
-          <a:xfrm>
-            <a:off x="914400" y="5212080"/>
-            <a:ext cx="2194560" cy="731520"/>
-          </a:xfrm>
-          <a:prstGeom prst="rect">
-            <a:avLst/>
-          </a:prstGeom>
-          <a:noFill/>
-        </p:spPr>
-        <p:txBody>
-          <a:bodyPr wrap="square">
-            <a:spAutoFit/>
-          </a:bodyPr>
-          <a:lstStyle/>
-          <a:p>
-            <a:pPr algn="ctr">
-              <a:defRPr sz="1600" b="1">
-                <a:solidFill>
-                  <a:srgbClr val="1B3A5C"/>
-                </a:solidFill>
-              </a:defRPr>
-            </a:pPr>
-            <a:r>
-              <a:t>10.000 USD</a:t>
-            </a:r>
-          </a:p>
-        </p:txBody>
-      </p:sp>
-      <p:sp>
-        <p:nvSpPr>
-          <p:cNvPr id="26" name="TextBox 25"/>
-          <p:cNvSpPr txBox="1"/>
-          <p:nvPr/>
-        </p:nvSpPr>
-        <p:spPr>
-          <a:xfrm>
-            <a:off x="3108960" y="5166360"/>
-            <a:ext cx="457200" cy="457200"/>
-          </a:xfrm>
-          <a:prstGeom prst="rect">
-            <a:avLst/>
-          </a:prstGeom>
-          <a:noFill/>
-        </p:spPr>
-        <p:txBody>
-          <a:bodyPr wrap="square">
-            <a:spAutoFit/>
-          </a:bodyPr>
-          <a:lstStyle/>
-          <a:p>
-            <a:pPr algn="ctr">
-              <a:defRPr sz="2000" b="0">
-                <a:solidFill>
-                  <a:srgbClr val="2E86AB"/>
-                </a:solidFill>
-              </a:defRPr>
-            </a:pPr>
-            <a:r>
-              <a:t>→</a:t>
-            </a:r>
-          </a:p>
-        </p:txBody>
-      </p:sp>
-      <p:sp>
-        <p:nvSpPr>
-          <p:cNvPr id="27" name="Rounded Rectangle 26"/>
-          <p:cNvSpPr/>
-          <p:nvPr/>
-        </p:nvSpPr>
-        <p:spPr>
-          <a:xfrm>
-            <a:off x="3566160" y="4800600"/>
-            <a:ext cx="2377440" cy="1371600"/>
-          </a:xfrm>
-          <a:prstGeom prst="roundRect">
-            <a:avLst/>
-          </a:prstGeom>
-          <a:solidFill>
-            <a:srgbClr val="E8F4F8"/>
-          </a:solidFill>
-          <a:ln>
-            <a:noFill/>
-          </a:ln>
-        </p:spPr>
-        <p:style>
-          <a:lnRef idx="1">
-            <a:schemeClr val="accent1"/>
-          </a:lnRef>
-          <a:fillRef idx="3">
-            <a:schemeClr val="accent1"/>
-          </a:fillRef>
-          <a:effectRef idx="2">
-            <a:schemeClr val="accent1"/>
-          </a:effectRef>
-          <a:fontRef idx="minor">
-            <a:schemeClr val="lt1"/>
-          </a:fontRef>
-        </p:style>
-        <p:txBody>
-          <a:bodyPr rtlCol="0" anchor="ctr"/>
-          <a:lstStyle/>
-          <a:p>
-            <a:pPr algn="ctr"/>
-            <a:endParaRPr/>
-          </a:p>
-        </p:txBody>
-      </p:sp>
-      <p:sp>
-        <p:nvSpPr>
-          <p:cNvPr id="28" name="TextBox 27"/>
-          <p:cNvSpPr txBox="1"/>
-          <p:nvPr/>
-        </p:nvSpPr>
-        <p:spPr>
-          <a:xfrm>
-            <a:off x="3657600" y="4846320"/>
-            <a:ext cx="2194560" cy="320040"/>
-          </a:xfrm>
-          <a:prstGeom prst="rect">
-            <a:avLst/>
-          </a:prstGeom>
-          <a:noFill/>
-        </p:spPr>
-        <p:txBody>
-          <a:bodyPr wrap="square">
-            <a:spAutoFit/>
-          </a:bodyPr>
-          <a:lstStyle/>
-          <a:p>
-            <a:pPr algn="ctr">
-              <a:defRPr sz="1100" b="1">
-                <a:solidFill>
-                  <a:srgbClr val="7F8C8D"/>
-                </a:solidFill>
-              </a:defRPr>
-            </a:pPr>
-            <a:r>
-              <a:t>Tỷ giá biến động</a:t>
-            </a:r>
-          </a:p>
-        </p:txBody>
-      </p:sp>
-      <p:sp>
-        <p:nvSpPr>
-          <p:cNvPr id="29" name="TextBox 28"/>
-          <p:cNvSpPr txBox="1"/>
-          <p:nvPr/>
-        </p:nvSpPr>
-        <p:spPr>
-          <a:xfrm>
-            <a:off x="3657600" y="5212080"/>
-            <a:ext cx="2194560" cy="731520"/>
-          </a:xfrm>
-          <a:prstGeom prst="rect">
-            <a:avLst/>
-          </a:prstGeom>
-          <a:noFill/>
-        </p:spPr>
-        <p:txBody>
-          <a:bodyPr wrap="square">
-            <a:spAutoFit/>
-          </a:bodyPr>
-          <a:lstStyle/>
-          <a:p>
-            <a:pPr algn="ctr">
-              <a:defRPr sz="1600" b="1">
-                <a:solidFill>
-                  <a:srgbClr val="1B3A5C"/>
-                </a:solidFill>
-              </a:defRPr>
-            </a:pPr>
-            <a:r>
-              <a:t>24.800 → 25.300 VND/USD</a:t>
-            </a:r>
-          </a:p>
-        </p:txBody>
-      </p:sp>
-      <p:sp>
-        <p:nvSpPr>
-          <p:cNvPr id="30" name="TextBox 29"/>
-          <p:cNvSpPr txBox="1"/>
-          <p:nvPr/>
-        </p:nvSpPr>
-        <p:spPr>
-          <a:xfrm>
-            <a:off x="5852160" y="5166360"/>
-            <a:ext cx="457200" cy="457200"/>
-          </a:xfrm>
-          <a:prstGeom prst="rect">
-            <a:avLst/>
-          </a:prstGeom>
-          <a:noFill/>
-        </p:spPr>
-        <p:txBody>
-          <a:bodyPr wrap="square">
-            <a:spAutoFit/>
-          </a:bodyPr>
-          <a:lstStyle/>
-          <a:p>
-            <a:pPr algn="ctr">
-              <a:defRPr sz="2000" b="0">
-                <a:solidFill>
-                  <a:srgbClr val="2E86AB"/>
-                </a:solidFill>
-              </a:defRPr>
-            </a:pPr>
-            <a:r>
-              <a:t>→</a:t>
-            </a:r>
-          </a:p>
-        </p:txBody>
-      </p:sp>
-      <p:sp>
-        <p:nvSpPr>
-          <p:cNvPr id="31" name="Rounded Rectangle 30"/>
-          <p:cNvSpPr/>
-          <p:nvPr/>
-        </p:nvSpPr>
-        <p:spPr>
-          <a:xfrm>
-            <a:off x="6309360" y="4800600"/>
-            <a:ext cx="2377440" cy="1371600"/>
-          </a:xfrm>
-          <a:prstGeom prst="roundRect">
-            <a:avLst/>
-          </a:prstGeom>
-          <a:solidFill>
-            <a:srgbClr val="E8F4F8"/>
-          </a:solidFill>
-          <a:ln>
-            <a:noFill/>
-          </a:ln>
-        </p:spPr>
-        <p:style>
-          <a:lnRef idx="1">
-            <a:schemeClr val="accent1"/>
-          </a:lnRef>
-          <a:fillRef idx="3">
-            <a:schemeClr val="accent1"/>
-          </a:fillRef>
-          <a:effectRef idx="2">
-            <a:schemeClr val="accent1"/>
-          </a:effectRef>
-          <a:fontRef idx="minor">
-            <a:schemeClr val="lt1"/>
-          </a:fontRef>
-        </p:style>
-        <p:txBody>
-          <a:bodyPr rtlCol="0" anchor="ctr"/>
-          <a:lstStyle/>
-          <a:p>
-            <a:pPr algn="ctr"/>
-            <a:endParaRPr/>
-          </a:p>
-        </p:txBody>
-      </p:sp>
-      <p:sp>
-        <p:nvSpPr>
-          <p:cNvPr id="32" name="TextBox 31"/>
-          <p:cNvSpPr txBox="1"/>
-          <p:nvPr/>
-        </p:nvSpPr>
-        <p:spPr>
-          <a:xfrm>
-            <a:off x="6400800" y="4846320"/>
-            <a:ext cx="2194560" cy="320040"/>
-          </a:xfrm>
-          <a:prstGeom prst="rect">
-            <a:avLst/>
-          </a:prstGeom>
-          <a:noFill/>
-        </p:spPr>
-        <p:txBody>
-          <a:bodyPr wrap="square">
-            <a:spAutoFit/>
-          </a:bodyPr>
-          <a:lstStyle/>
-          <a:p>
-            <a:pPr algn="ctr">
-              <a:defRPr sz="1100" b="1">
-                <a:solidFill>
-                  <a:srgbClr val="7F8C8D"/>
-                </a:solidFill>
-              </a:defRPr>
-            </a:pPr>
-            <a:r>
-              <a:t>Chênh lệch</a:t>
-            </a:r>
-          </a:p>
-        </p:txBody>
-      </p:sp>
-      <p:sp>
-        <p:nvSpPr>
-          <p:cNvPr id="33" name="TextBox 32"/>
-          <p:cNvSpPr txBox="1"/>
-          <p:nvPr/>
-        </p:nvSpPr>
-        <p:spPr>
-          <a:xfrm>
-            <a:off x="6400800" y="5212080"/>
-            <a:ext cx="2194560" cy="731520"/>
-          </a:xfrm>
-          <a:prstGeom prst="rect">
-            <a:avLst/>
-          </a:prstGeom>
-          <a:noFill/>
-        </p:spPr>
-        <p:txBody>
-          <a:bodyPr wrap="square">
-            <a:spAutoFit/>
-          </a:bodyPr>
-          <a:lstStyle/>
-          <a:p>
-            <a:pPr algn="ctr">
-              <a:defRPr sz="1600" b="1">
-                <a:solidFill>
-                  <a:srgbClr val="1B3A5C"/>
-                </a:solidFill>
-              </a:defRPr>
-            </a:pPr>
-            <a:r>
-              <a:t>+500 VND/USD</a:t>
-            </a:r>
-          </a:p>
-        </p:txBody>
-      </p:sp>
-      <p:sp>
-        <p:nvSpPr>
-          <p:cNvPr id="34" name="TextBox 33"/>
-          <p:cNvSpPr txBox="1"/>
-          <p:nvPr/>
-        </p:nvSpPr>
-        <p:spPr>
-          <a:xfrm>
-            <a:off x="8595360" y="5166360"/>
-            <a:ext cx="457200" cy="457200"/>
-          </a:xfrm>
-          <a:prstGeom prst="rect">
-            <a:avLst/>
-          </a:prstGeom>
-          <a:noFill/>
-        </p:spPr>
-        <p:txBody>
-          <a:bodyPr wrap="square">
-            <a:spAutoFit/>
-          </a:bodyPr>
-          <a:lstStyle/>
-          <a:p>
-            <a:pPr algn="ctr">
-              <a:defRPr sz="2000" b="0">
-                <a:solidFill>
-                  <a:srgbClr val="2E86AB"/>
-                </a:solidFill>
-              </a:defRPr>
-            </a:pPr>
-            <a:r>
-              <a:t>→</a:t>
-            </a:r>
-          </a:p>
-        </p:txBody>
-      </p:sp>
-      <p:sp>
-        <p:nvSpPr>
-          <p:cNvPr id="35" name="Rounded Rectangle 34"/>
-          <p:cNvSpPr/>
-          <p:nvPr/>
-        </p:nvSpPr>
-        <p:spPr>
-          <a:xfrm>
-            <a:off x="9052560" y="4800600"/>
-            <a:ext cx="2377440" cy="1371600"/>
-          </a:xfrm>
-          <a:prstGeom prst="roundRect">
-            <a:avLst/>
-          </a:prstGeom>
-          <a:solidFill>
-            <a:srgbClr val="E8F4F8"/>
-          </a:solidFill>
-          <a:ln>
-            <a:noFill/>
-          </a:ln>
-        </p:spPr>
-        <p:style>
-          <a:lnRef idx="1">
-            <a:schemeClr val="accent1"/>
-          </a:lnRef>
-          <a:fillRef idx="3">
-            <a:schemeClr val="accent1"/>
-          </a:fillRef>
-          <a:effectRef idx="2">
-            <a:schemeClr val="accent1"/>
-          </a:effectRef>
-          <a:fontRef idx="minor">
-            <a:schemeClr val="lt1"/>
-          </a:fontRef>
-        </p:style>
-        <p:txBody>
-          <a:bodyPr rtlCol="0" anchor="ctr"/>
-          <a:lstStyle/>
-          <a:p>
-            <a:pPr algn="ctr"/>
-            <a:endParaRPr/>
-          </a:p>
-        </p:txBody>
-      </p:sp>
-      <p:sp>
-        <p:nvSpPr>
-          <p:cNvPr id="36" name="TextBox 35"/>
-          <p:cNvSpPr txBox="1"/>
-          <p:nvPr/>
-        </p:nvSpPr>
-        <p:spPr>
-          <a:xfrm>
-            <a:off x="9144000" y="4846320"/>
-            <a:ext cx="2194560" cy="320040"/>
-          </a:xfrm>
-          <a:prstGeom prst="rect">
-            <a:avLst/>
-          </a:prstGeom>
-          <a:noFill/>
-        </p:spPr>
-        <p:txBody>
-          <a:bodyPr wrap="square">
-            <a:spAutoFit/>
-          </a:bodyPr>
-          <a:lstStyle/>
-          <a:p>
-            <a:pPr algn="ctr">
-              <a:defRPr sz="1100" b="1">
-                <a:solidFill>
-                  <a:srgbClr val="7F8C8D"/>
-                </a:solidFill>
-              </a:defRPr>
-            </a:pPr>
-            <a:r>
-              <a:t>Tác động</a:t>
-            </a:r>
-          </a:p>
-        </p:txBody>
-      </p:sp>
-      <p:sp>
-        <p:nvSpPr>
-          <p:cNvPr id="37" name="TextBox 36"/>
-          <p:cNvSpPr txBox="1"/>
-          <p:nvPr/>
-        </p:nvSpPr>
-        <p:spPr>
-          <a:xfrm>
-            <a:off x="9144000" y="5212080"/>
-            <a:ext cx="2194560" cy="731520"/>
-          </a:xfrm>
-          <a:prstGeom prst="rect">
-            <a:avLst/>
-          </a:prstGeom>
-          <a:noFill/>
-        </p:spPr>
-        <p:txBody>
-          <a:bodyPr wrap="square">
-            <a:spAutoFit/>
-          </a:bodyPr>
-          <a:lstStyle/>
-          <a:p>
-            <a:pPr algn="ctr">
-              <a:defRPr sz="1600" b="1">
-                <a:solidFill>
-                  <a:srgbClr val="1B3A5C"/>
-                </a:solidFill>
-              </a:defRPr>
-            </a:pPr>
-            <a:r>
-              <a:t>+5.000.000 VND/tháng</a:t>
             </a:r>
           </a:p>
         </p:txBody>
@@ -9001,14 +8309,267 @@
       </p:sp>
       <p:sp>
         <p:nvSpPr>
-          <p:cNvPr id="12" name="Rounded Rectangle 11"/>
+          <p:cNvPr id="20" name="TextBox 19"/>
+          <p:cNvSpPr txBox="1"/>
+          <p:nvPr/>
+        </p:nvSpPr>
+        <p:spPr>
+          <a:xfrm>
+            <a:off x="548640" y="4023360"/>
+            <a:ext cx="10972800" cy="338554"/>
+          </a:xfrm>
+          <a:prstGeom prst="rect">
+            <a:avLst/>
+          </a:prstGeom>
+          <a:noFill/>
+        </p:spPr>
+        <p:txBody>
+          <a:bodyPr wrap="square">
+            <a:spAutoFit/>
+          </a:bodyPr>
+          <a:lstStyle/>
+          <a:p>
+            <a:pPr algn="l">
+              <a:defRPr sz="1600" b="1">
+                <a:solidFill>
+                  <a:srgbClr val="1B3A5C"/>
+                </a:solidFill>
+              </a:defRPr>
+            </a:pPr>
+            <a:r>
+              <a:rPr dirty="0"/>
+              <a:t>TÁC ĐỘNG KHI GIÁ XĂNG TĂNG </a:t>
+            </a:r>
+            <a:r>
+              <a:rPr lang="en-US" dirty="0"/>
+              <a:t>-</a:t>
+            </a:r>
+            <a:r>
+              <a:rPr dirty="0"/>
+              <a:t> </a:t>
+            </a:r>
+            <a:r>
+              <a:rPr dirty="0" err="1"/>
+              <a:t>Góc</a:t>
+            </a:r>
+            <a:r>
+              <a:rPr dirty="0"/>
+              <a:t> </a:t>
+            </a:r>
+            <a:r>
+              <a:rPr dirty="0" err="1"/>
+              <a:t>nhìn</a:t>
+            </a:r>
+            <a:r>
+              <a:rPr dirty="0"/>
+              <a:t> Quản </a:t>
+            </a:r>
+            <a:r>
+              <a:rPr dirty="0" err="1"/>
+              <a:t>trị</a:t>
+            </a:r>
+            <a:r>
+              <a:rPr dirty="0"/>
+              <a:t> </a:t>
+            </a:r>
+            <a:r>
+              <a:rPr dirty="0" err="1"/>
+              <a:t>nhân</a:t>
+            </a:r>
+            <a:r>
+              <a:rPr dirty="0"/>
+              <a:t> </a:t>
+            </a:r>
+            <a:r>
+              <a:rPr dirty="0" err="1"/>
+              <a:t>sự</a:t>
+            </a:r>
+            <a:endParaRPr dirty="0"/>
+          </a:p>
+        </p:txBody>
+      </p:sp>
+      <p:sp>
+        <p:nvSpPr>
+          <p:cNvPr id="21" name="Rounded Rectangle 20"/>
           <p:cNvSpPr/>
           <p:nvPr/>
         </p:nvSpPr>
         <p:spPr>
           <a:xfrm>
-            <a:off x="6309360" y="1463040"/>
-            <a:ext cx="5303520" cy="2194560"/>
+            <a:off x="1645919" y="4482353"/>
+            <a:ext cx="2651760" cy="2011680"/>
+          </a:xfrm>
+          <a:prstGeom prst="roundRect">
+            <a:avLst/>
+          </a:prstGeom>
+          <a:solidFill>
+            <a:srgbClr val="FFFFFF"/>
+          </a:solidFill>
+          <a:ln w="19050">
+            <a:solidFill>
+              <a:srgbClr val="C0392B"/>
+            </a:solidFill>
+          </a:ln>
+        </p:spPr>
+        <p:style>
+          <a:lnRef idx="1">
+            <a:schemeClr val="accent1"/>
+          </a:lnRef>
+          <a:fillRef idx="3">
+            <a:schemeClr val="accent1"/>
+          </a:fillRef>
+          <a:effectRef idx="2">
+            <a:schemeClr val="accent1"/>
+          </a:effectRef>
+          <a:fontRef idx="minor">
+            <a:schemeClr val="lt1"/>
+          </a:fontRef>
+        </p:style>
+        <p:txBody>
+          <a:bodyPr rtlCol="0" anchor="ctr"/>
+          <a:lstStyle/>
+          <a:p>
+            <a:pPr algn="ctr"/>
+            <a:endParaRPr/>
+          </a:p>
+        </p:txBody>
+      </p:sp>
+      <p:sp>
+        <p:nvSpPr>
+          <p:cNvPr id="22" name="Oval 21"/>
+          <p:cNvSpPr/>
+          <p:nvPr/>
+        </p:nvSpPr>
+        <p:spPr>
+          <a:xfrm>
+            <a:off x="1783079" y="4619513"/>
+            <a:ext cx="502920" cy="502920"/>
+          </a:xfrm>
+          <a:prstGeom prst="ellipse">
+            <a:avLst/>
+          </a:prstGeom>
+          <a:solidFill>
+            <a:srgbClr val="C0392B"/>
+          </a:solidFill>
+          <a:ln>
+            <a:noFill/>
+          </a:ln>
+        </p:spPr>
+        <p:style>
+          <a:lnRef idx="1">
+            <a:schemeClr val="accent1"/>
+          </a:lnRef>
+          <a:fillRef idx="3">
+            <a:schemeClr val="accent1"/>
+          </a:fillRef>
+          <a:effectRef idx="2">
+            <a:schemeClr val="accent1"/>
+          </a:effectRef>
+          <a:fontRef idx="minor">
+            <a:schemeClr val="lt1"/>
+          </a:fontRef>
+        </p:style>
+        <p:txBody>
+          <a:bodyPr rtlCol="0" anchor="ctr"/>
+          <a:lstStyle/>
+          <a:p>
+            <a:pPr algn="ctr">
+              <a:defRPr sz="1800">
+                <a:solidFill>
+                  <a:srgbClr val="FFFFFF"/>
+                </a:solidFill>
+              </a:defRPr>
+            </a:pPr>
+            <a:r>
+              <a:t>⚠️</a:t>
+            </a:r>
+          </a:p>
+        </p:txBody>
+      </p:sp>
+      <p:sp>
+        <p:nvSpPr>
+          <p:cNvPr id="23" name="TextBox 22"/>
+          <p:cNvSpPr txBox="1"/>
+          <p:nvPr/>
+        </p:nvSpPr>
+        <p:spPr>
+          <a:xfrm>
+            <a:off x="2377439" y="4665233"/>
+            <a:ext cx="1737360" cy="320040"/>
+          </a:xfrm>
+          <a:prstGeom prst="rect">
+            <a:avLst/>
+          </a:prstGeom>
+          <a:noFill/>
+        </p:spPr>
+        <p:txBody>
+          <a:bodyPr wrap="square">
+            <a:spAutoFit/>
+          </a:bodyPr>
+          <a:lstStyle/>
+          <a:p>
+            <a:pPr algn="l">
+              <a:defRPr sz="1400" b="1">
+                <a:solidFill>
+                  <a:srgbClr val="C0392B"/>
+                </a:solidFill>
+              </a:defRPr>
+            </a:pPr>
+            <a:r>
+              <a:t>Chi phí DN</a:t>
+            </a:r>
+          </a:p>
+        </p:txBody>
+      </p:sp>
+      <p:sp>
+        <p:nvSpPr>
+          <p:cNvPr id="24" name="TextBox 23"/>
+          <p:cNvSpPr txBox="1"/>
+          <p:nvPr/>
+        </p:nvSpPr>
+        <p:spPr>
+          <a:xfrm>
+            <a:off x="1828799" y="5213873"/>
+            <a:ext cx="2286000" cy="1097280"/>
+          </a:xfrm>
+          <a:prstGeom prst="rect">
+            <a:avLst/>
+          </a:prstGeom>
+          <a:noFill/>
+        </p:spPr>
+        <p:txBody>
+          <a:bodyPr wrap="square">
+            <a:spAutoFit/>
+          </a:bodyPr>
+          <a:lstStyle/>
+          <a:p>
+            <a:pPr algn="ctr">
+              <a:defRPr sz="1200" b="0">
+                <a:solidFill>
+                  <a:srgbClr val="2D3A4A"/>
+                </a:solidFill>
+              </a:defRPr>
+            </a:pPr>
+            <a:r>
+              <a:t>Tổng trợ cấp tăng</a:t>
+            </a:r>
+            <a:br/>
+            <a:r>
+              <a:t>theo headcount</a:t>
+            </a:r>
+          </a:p>
+        </p:txBody>
+      </p:sp>
+      <p:sp>
+        <p:nvSpPr>
+          <p:cNvPr id="25" name="Rounded Rectangle 24"/>
+          <p:cNvSpPr/>
+          <p:nvPr/>
+        </p:nvSpPr>
+        <p:spPr>
+          <a:xfrm>
+            <a:off x="4526279" y="4482353"/>
+            <a:ext cx="2651760" cy="2011680"/>
           </a:xfrm>
           <a:prstGeom prst="roundRect">
             <a:avLst/>
@@ -9047,209 +8608,16 @@
       </p:sp>
       <p:sp>
         <p:nvSpPr>
-          <p:cNvPr id="13" name="TextBox 12"/>
-          <p:cNvSpPr txBox="1"/>
-          <p:nvPr/>
-        </p:nvSpPr>
-        <p:spPr>
-          <a:xfrm>
-            <a:off x="6583680" y="1554480"/>
-            <a:ext cx="4754880" cy="365760"/>
-          </a:xfrm>
-          <a:prstGeom prst="rect">
-            <a:avLst/>
-          </a:prstGeom>
-          <a:noFill/>
-        </p:spPr>
-        <p:txBody>
-          <a:bodyPr wrap="square">
-            <a:spAutoFit/>
-          </a:bodyPr>
-          <a:lstStyle/>
-          <a:p>
-            <a:pPr algn="l">
-              <a:defRPr sz="1500" b="1">
-                <a:solidFill>
-                  <a:srgbClr val="E86C00"/>
-                </a:solidFill>
-              </a:defRPr>
-            </a:pPr>
-            <a:r>
-              <a:t>🧮 VÍ DỤ: Nhân viên cách 20 km</a:t>
-            </a:r>
-          </a:p>
-        </p:txBody>
-      </p:sp>
-      <p:sp>
-        <p:nvSpPr>
-          <p:cNvPr id="14" name="Rounded Rectangle 13"/>
+          <p:cNvPr id="26" name="Oval 25"/>
           <p:cNvSpPr/>
           <p:nvPr/>
         </p:nvSpPr>
         <p:spPr>
           <a:xfrm>
-            <a:off x="6583680" y="2103120"/>
-            <a:ext cx="4754880" cy="365760"/>
-          </a:xfrm>
-          <a:prstGeom prst="roundRect">
-            <a:avLst/>
-          </a:prstGeom>
-          <a:solidFill>
-            <a:srgbClr val="FDF2E9"/>
-          </a:solidFill>
-          <a:ln>
-            <a:noFill/>
-          </a:ln>
-        </p:spPr>
-        <p:style>
-          <a:lnRef idx="1">
-            <a:schemeClr val="accent1"/>
-          </a:lnRef>
-          <a:fillRef idx="3">
-            <a:schemeClr val="accent1"/>
-          </a:fillRef>
-          <a:effectRef idx="2">
-            <a:schemeClr val="accent1"/>
-          </a:effectRef>
-          <a:fontRef idx="minor">
-            <a:schemeClr val="lt1"/>
-          </a:fontRef>
-        </p:style>
-        <p:txBody>
-          <a:bodyPr rtlCol="0" anchor="ctr"/>
-          <a:lstStyle/>
-          <a:p>
-            <a:pPr algn="ctr"/>
-            <a:endParaRPr/>
-          </a:p>
-        </p:txBody>
-      </p:sp>
-      <p:sp>
-        <p:nvSpPr>
-          <p:cNvPr id="15" name="TextBox 14"/>
-          <p:cNvSpPr txBox="1"/>
-          <p:nvPr/>
-        </p:nvSpPr>
-        <p:spPr>
-          <a:xfrm>
-            <a:off x="6766560" y="2103120"/>
-            <a:ext cx="4389120" cy="365760"/>
-          </a:xfrm>
-          <a:prstGeom prst="rect">
-            <a:avLst/>
-          </a:prstGeom>
-          <a:noFill/>
-        </p:spPr>
-        <p:txBody>
-          <a:bodyPr wrap="square">
-            <a:spAutoFit/>
-          </a:bodyPr>
-          <a:lstStyle/>
-          <a:p>
-            <a:pPr algn="l">
-              <a:defRPr sz="1300" b="0">
-                <a:solidFill>
-                  <a:srgbClr val="2D3A4A"/>
-                </a:solidFill>
-              </a:defRPr>
-            </a:pPr>
-            <a:r>
-              <a:t>Bước 1: 20 km × 2 chiều = 40 km/ngày</a:t>
-            </a:r>
-          </a:p>
-        </p:txBody>
-      </p:sp>
-      <p:sp>
-        <p:nvSpPr>
-          <p:cNvPr id="16" name="Rounded Rectangle 15"/>
-          <p:cNvSpPr/>
-          <p:nvPr/>
-        </p:nvSpPr>
-        <p:spPr>
-          <a:xfrm>
-            <a:off x="6583680" y="2560320"/>
-            <a:ext cx="4754880" cy="365760"/>
-          </a:xfrm>
-          <a:prstGeom prst="roundRect">
-            <a:avLst/>
-          </a:prstGeom>
-          <a:solidFill>
-            <a:srgbClr val="FDF2E9"/>
-          </a:solidFill>
-          <a:ln>
-            <a:noFill/>
-          </a:ln>
-        </p:spPr>
-        <p:style>
-          <a:lnRef idx="1">
-            <a:schemeClr val="accent1"/>
-          </a:lnRef>
-          <a:fillRef idx="3">
-            <a:schemeClr val="accent1"/>
-          </a:fillRef>
-          <a:effectRef idx="2">
-            <a:schemeClr val="accent1"/>
-          </a:effectRef>
-          <a:fontRef idx="minor">
-            <a:schemeClr val="lt1"/>
-          </a:fontRef>
-        </p:style>
-        <p:txBody>
-          <a:bodyPr rtlCol="0" anchor="ctr"/>
-          <a:lstStyle/>
-          <a:p>
-            <a:pPr algn="ctr"/>
-            <a:endParaRPr/>
-          </a:p>
-        </p:txBody>
-      </p:sp>
-      <p:sp>
-        <p:nvSpPr>
-          <p:cNvPr id="17" name="TextBox 16"/>
-          <p:cNvSpPr txBox="1"/>
-          <p:nvPr/>
-        </p:nvSpPr>
-        <p:spPr>
-          <a:xfrm>
-            <a:off x="6766560" y="2560320"/>
-            <a:ext cx="4389120" cy="365760"/>
-          </a:xfrm>
-          <a:prstGeom prst="rect">
-            <a:avLst/>
-          </a:prstGeom>
-          <a:noFill/>
-        </p:spPr>
-        <p:txBody>
-          <a:bodyPr wrap="square">
-            <a:spAutoFit/>
-          </a:bodyPr>
-          <a:lstStyle/>
-          <a:p>
-            <a:pPr algn="l">
-              <a:defRPr sz="1300" b="0">
-                <a:solidFill>
-                  <a:srgbClr val="2D3A4A"/>
-                </a:solidFill>
-              </a:defRPr>
-            </a:pPr>
-            <a:r>
-              <a:t>Bước 2: 40 km × 2.500 đ = 100.000 đ/ngày</a:t>
-            </a:r>
-          </a:p>
-        </p:txBody>
-      </p:sp>
-      <p:sp>
-        <p:nvSpPr>
-          <p:cNvPr id="18" name="Rounded Rectangle 17"/>
-          <p:cNvSpPr/>
-          <p:nvPr/>
-        </p:nvSpPr>
-        <p:spPr>
-          <a:xfrm>
-            <a:off x="6583680" y="3017520"/>
-            <a:ext cx="4754880" cy="365760"/>
-          </a:xfrm>
-          <a:prstGeom prst="roundRect">
+            <a:off x="4663439" y="4619513"/>
+            <a:ext cx="502920" cy="502920"/>
+          </a:xfrm>
+          <a:prstGeom prst="ellipse">
             <a:avLst/>
           </a:prstGeom>
           <a:solidFill>
@@ -9277,21 +8645,29 @@
           <a:bodyPr rtlCol="0" anchor="ctr"/>
           <a:lstStyle/>
           <a:p>
-            <a:pPr algn="ctr"/>
-            <a:endParaRPr/>
-          </a:p>
-        </p:txBody>
-      </p:sp>
-      <p:sp>
-        <p:nvSpPr>
-          <p:cNvPr id="19" name="TextBox 18"/>
+            <a:pPr algn="ctr">
+              <a:defRPr sz="1800">
+                <a:solidFill>
+                  <a:srgbClr val="FFFFFF"/>
+                </a:solidFill>
+              </a:defRPr>
+            </a:pPr>
+            <a:r>
+              <a:t>😤</a:t>
+            </a:r>
+          </a:p>
+        </p:txBody>
+      </p:sp>
+      <p:sp>
+        <p:nvSpPr>
+          <p:cNvPr id="27" name="TextBox 26"/>
           <p:cNvSpPr txBox="1"/>
           <p:nvPr/>
         </p:nvSpPr>
         <p:spPr>
           <a:xfrm>
-            <a:off x="6766560" y="3017520"/>
-            <a:ext cx="4389120" cy="365760"/>
+            <a:off x="5257799" y="4665233"/>
+            <a:ext cx="1737360" cy="320040"/>
           </a:xfrm>
           <a:prstGeom prst="rect">
             <a:avLst/>
@@ -9305,28 +8681,28 @@
           <a:lstStyle/>
           <a:p>
             <a:pPr algn="l">
-              <a:defRPr sz="1300" b="1">
-                <a:solidFill>
-                  <a:srgbClr val="FFFFFF"/>
+              <a:defRPr sz="1400" b="1">
+                <a:solidFill>
+                  <a:srgbClr val="E86C00"/>
                 </a:solidFill>
               </a:defRPr>
             </a:pPr>
             <a:r>
-              <a:t>Bước 3: 100.000 đ × 22 ngày = 2.200.000 đ/tháng</a:t>
-            </a:r>
-          </a:p>
-        </p:txBody>
-      </p:sp>
-      <p:sp>
-        <p:nvSpPr>
-          <p:cNvPr id="20" name="TextBox 19"/>
+              <a:t>Hài lòng NV</a:t>
+            </a:r>
+          </a:p>
+        </p:txBody>
+      </p:sp>
+      <p:sp>
+        <p:nvSpPr>
+          <p:cNvPr id="28" name="TextBox 27"/>
           <p:cNvSpPr txBox="1"/>
           <p:nvPr/>
         </p:nvSpPr>
         <p:spPr>
           <a:xfrm>
-            <a:off x="548640" y="4023360"/>
-            <a:ext cx="10972800" cy="411480"/>
+            <a:off x="4709159" y="5213873"/>
+            <a:ext cx="2286000" cy="1097280"/>
           </a:xfrm>
           <a:prstGeom prst="rect">
             <a:avLst/>
@@ -9339,174 +8715,6 @@
           </a:bodyPr>
           <a:lstStyle/>
           <a:p>
-            <a:pPr algn="l">
-              <a:defRPr sz="1600" b="1">
-                <a:solidFill>
-                  <a:srgbClr val="1B3A5C"/>
-                </a:solidFill>
-              </a:defRPr>
-            </a:pPr>
-            <a:r>
-              <a:t>TÁC ĐỘNG KHI GIÁ XĂNG TĂNG — Góc nhìn Quản trị nhân sự</a:t>
-            </a:r>
-          </a:p>
-        </p:txBody>
-      </p:sp>
-      <p:sp>
-        <p:nvSpPr>
-          <p:cNvPr id="21" name="Rounded Rectangle 20"/>
-          <p:cNvSpPr/>
-          <p:nvPr/>
-        </p:nvSpPr>
-        <p:spPr>
-          <a:xfrm>
-            <a:off x="548640" y="4480560"/>
-            <a:ext cx="2651760" cy="2011680"/>
-          </a:xfrm>
-          <a:prstGeom prst="roundRect">
-            <a:avLst/>
-          </a:prstGeom>
-          <a:solidFill>
-            <a:srgbClr val="FFFFFF"/>
-          </a:solidFill>
-          <a:ln w="19050">
-            <a:solidFill>
-              <a:srgbClr val="C0392B"/>
-            </a:solidFill>
-          </a:ln>
-        </p:spPr>
-        <p:style>
-          <a:lnRef idx="1">
-            <a:schemeClr val="accent1"/>
-          </a:lnRef>
-          <a:fillRef idx="3">
-            <a:schemeClr val="accent1"/>
-          </a:fillRef>
-          <a:effectRef idx="2">
-            <a:schemeClr val="accent1"/>
-          </a:effectRef>
-          <a:fontRef idx="minor">
-            <a:schemeClr val="lt1"/>
-          </a:fontRef>
-        </p:style>
-        <p:txBody>
-          <a:bodyPr rtlCol="0" anchor="ctr"/>
-          <a:lstStyle/>
-          <a:p>
-            <a:pPr algn="ctr"/>
-            <a:endParaRPr/>
-          </a:p>
-        </p:txBody>
-      </p:sp>
-      <p:sp>
-        <p:nvSpPr>
-          <p:cNvPr id="22" name="Oval 21"/>
-          <p:cNvSpPr/>
-          <p:nvPr/>
-        </p:nvSpPr>
-        <p:spPr>
-          <a:xfrm>
-            <a:off x="685800" y="4617720"/>
-            <a:ext cx="502920" cy="502920"/>
-          </a:xfrm>
-          <a:prstGeom prst="ellipse">
-            <a:avLst/>
-          </a:prstGeom>
-          <a:solidFill>
-            <a:srgbClr val="C0392B"/>
-          </a:solidFill>
-          <a:ln>
-            <a:noFill/>
-          </a:ln>
-        </p:spPr>
-        <p:style>
-          <a:lnRef idx="1">
-            <a:schemeClr val="accent1"/>
-          </a:lnRef>
-          <a:fillRef idx="3">
-            <a:schemeClr val="accent1"/>
-          </a:fillRef>
-          <a:effectRef idx="2">
-            <a:schemeClr val="accent1"/>
-          </a:effectRef>
-          <a:fontRef idx="minor">
-            <a:schemeClr val="lt1"/>
-          </a:fontRef>
-        </p:style>
-        <p:txBody>
-          <a:bodyPr rtlCol="0" anchor="ctr"/>
-          <a:lstStyle/>
-          <a:p>
-            <a:pPr algn="ctr">
-              <a:defRPr sz="1800">
-                <a:solidFill>
-                  <a:srgbClr val="FFFFFF"/>
-                </a:solidFill>
-              </a:defRPr>
-            </a:pPr>
-            <a:r>
-              <a:t>⚠️</a:t>
-            </a:r>
-          </a:p>
-        </p:txBody>
-      </p:sp>
-      <p:sp>
-        <p:nvSpPr>
-          <p:cNvPr id="23" name="TextBox 22"/>
-          <p:cNvSpPr txBox="1"/>
-          <p:nvPr/>
-        </p:nvSpPr>
-        <p:spPr>
-          <a:xfrm>
-            <a:off x="1280160" y="4663440"/>
-            <a:ext cx="1737360" cy="320040"/>
-          </a:xfrm>
-          <a:prstGeom prst="rect">
-            <a:avLst/>
-          </a:prstGeom>
-          <a:noFill/>
-        </p:spPr>
-        <p:txBody>
-          <a:bodyPr wrap="square">
-            <a:spAutoFit/>
-          </a:bodyPr>
-          <a:lstStyle/>
-          <a:p>
-            <a:pPr algn="l">
-              <a:defRPr sz="1400" b="1">
-                <a:solidFill>
-                  <a:srgbClr val="C0392B"/>
-                </a:solidFill>
-              </a:defRPr>
-            </a:pPr>
-            <a:r>
-              <a:t>Chi phí DN</a:t>
-            </a:r>
-          </a:p>
-        </p:txBody>
-      </p:sp>
-      <p:sp>
-        <p:nvSpPr>
-          <p:cNvPr id="24" name="TextBox 23"/>
-          <p:cNvSpPr txBox="1"/>
-          <p:nvPr/>
-        </p:nvSpPr>
-        <p:spPr>
-          <a:xfrm>
-            <a:off x="731520" y="5212080"/>
-            <a:ext cx="2286000" cy="1097280"/>
-          </a:xfrm>
-          <a:prstGeom prst="rect">
-            <a:avLst/>
-          </a:prstGeom>
-          <a:noFill/>
-        </p:spPr>
-        <p:txBody>
-          <a:bodyPr wrap="square">
-            <a:spAutoFit/>
-          </a:bodyPr>
-          <a:lstStyle/>
-          <a:p>
             <a:pPr algn="ctr">
               <a:defRPr sz="1200" b="0">
                 <a:solidFill>
@@ -9515,355 +8723,11 @@
               </a:defRPr>
             </a:pPr>
             <a:r>
-              <a:t>Tổng trợ cấp tăng</a:t>
+              <a:t>Mức cố định/km không</a:t>
             </a:r>
             <a:br/>
             <a:r>
-              <a:t>theo headcount</a:t>
-            </a:r>
-          </a:p>
-        </p:txBody>
-      </p:sp>
-      <p:sp>
-        <p:nvSpPr>
-          <p:cNvPr id="25" name="Rounded Rectangle 24"/>
-          <p:cNvSpPr/>
-          <p:nvPr/>
-        </p:nvSpPr>
-        <p:spPr>
-          <a:xfrm>
-            <a:off x="3429000" y="4480560"/>
-            <a:ext cx="2651760" cy="2011680"/>
-          </a:xfrm>
-          <a:prstGeom prst="roundRect">
-            <a:avLst/>
-          </a:prstGeom>
-          <a:solidFill>
-            <a:srgbClr val="FFFFFF"/>
-          </a:solidFill>
-          <a:ln w="19050">
-            <a:solidFill>
-              <a:srgbClr val="E86C00"/>
-            </a:solidFill>
-          </a:ln>
-        </p:spPr>
-        <p:style>
-          <a:lnRef idx="1">
-            <a:schemeClr val="accent1"/>
-          </a:lnRef>
-          <a:fillRef idx="3">
-            <a:schemeClr val="accent1"/>
-          </a:fillRef>
-          <a:effectRef idx="2">
-            <a:schemeClr val="accent1"/>
-          </a:effectRef>
-          <a:fontRef idx="minor">
-            <a:schemeClr val="lt1"/>
-          </a:fontRef>
-        </p:style>
-        <p:txBody>
-          <a:bodyPr rtlCol="0" anchor="ctr"/>
-          <a:lstStyle/>
-          <a:p>
-            <a:pPr algn="ctr"/>
-            <a:endParaRPr/>
-          </a:p>
-        </p:txBody>
-      </p:sp>
-      <p:sp>
-        <p:nvSpPr>
-          <p:cNvPr id="26" name="Oval 25"/>
-          <p:cNvSpPr/>
-          <p:nvPr/>
-        </p:nvSpPr>
-        <p:spPr>
-          <a:xfrm>
-            <a:off x="3566160" y="4617720"/>
-            <a:ext cx="502920" cy="502920"/>
-          </a:xfrm>
-          <a:prstGeom prst="ellipse">
-            <a:avLst/>
-          </a:prstGeom>
-          <a:solidFill>
-            <a:srgbClr val="E86C00"/>
-          </a:solidFill>
-          <a:ln>
-            <a:noFill/>
-          </a:ln>
-        </p:spPr>
-        <p:style>
-          <a:lnRef idx="1">
-            <a:schemeClr val="accent1"/>
-          </a:lnRef>
-          <a:fillRef idx="3">
-            <a:schemeClr val="accent1"/>
-          </a:fillRef>
-          <a:effectRef idx="2">
-            <a:schemeClr val="accent1"/>
-          </a:effectRef>
-          <a:fontRef idx="minor">
-            <a:schemeClr val="lt1"/>
-          </a:fontRef>
-        </p:style>
-        <p:txBody>
-          <a:bodyPr rtlCol="0" anchor="ctr"/>
-          <a:lstStyle/>
-          <a:p>
-            <a:pPr algn="ctr">
-              <a:defRPr sz="1800">
-                <a:solidFill>
-                  <a:srgbClr val="FFFFFF"/>
-                </a:solidFill>
-              </a:defRPr>
-            </a:pPr>
-            <a:r>
-              <a:t>😤</a:t>
-            </a:r>
-          </a:p>
-        </p:txBody>
-      </p:sp>
-      <p:sp>
-        <p:nvSpPr>
-          <p:cNvPr id="27" name="TextBox 26"/>
-          <p:cNvSpPr txBox="1"/>
-          <p:nvPr/>
-        </p:nvSpPr>
-        <p:spPr>
-          <a:xfrm>
-            <a:off x="4160520" y="4663440"/>
-            <a:ext cx="1737360" cy="320040"/>
-          </a:xfrm>
-          <a:prstGeom prst="rect">
-            <a:avLst/>
-          </a:prstGeom>
-          <a:noFill/>
-        </p:spPr>
-        <p:txBody>
-          <a:bodyPr wrap="square">
-            <a:spAutoFit/>
-          </a:bodyPr>
-          <a:lstStyle/>
-          <a:p>
-            <a:pPr algn="l">
-              <a:defRPr sz="1400" b="1">
-                <a:solidFill>
-                  <a:srgbClr val="E86C00"/>
-                </a:solidFill>
-              </a:defRPr>
-            </a:pPr>
-            <a:r>
-              <a:t>Hài lòng NV</a:t>
-            </a:r>
-          </a:p>
-        </p:txBody>
-      </p:sp>
-      <p:sp>
-        <p:nvSpPr>
-          <p:cNvPr id="28" name="TextBox 27"/>
-          <p:cNvSpPr txBox="1"/>
-          <p:nvPr/>
-        </p:nvSpPr>
-        <p:spPr>
-          <a:xfrm>
-            <a:off x="3611880" y="5212080"/>
-            <a:ext cx="2286000" cy="1097280"/>
-          </a:xfrm>
-          <a:prstGeom prst="rect">
-            <a:avLst/>
-          </a:prstGeom>
-          <a:noFill/>
-        </p:spPr>
-        <p:txBody>
-          <a:bodyPr wrap="square">
-            <a:spAutoFit/>
-          </a:bodyPr>
-          <a:lstStyle/>
-          <a:p>
-            <a:pPr algn="ctr">
-              <a:defRPr sz="1200" b="0">
-                <a:solidFill>
-                  <a:srgbClr val="2D3A4A"/>
-                </a:solidFill>
-              </a:defRPr>
-            </a:pPr>
-            <a:r>
-              <a:t>Mức cố định/km không</a:t>
-            </a:r>
-            <a:br/>
-            <a:r>
               <a:t>bù đủ chi phí thực tế</a:t>
-            </a:r>
-          </a:p>
-        </p:txBody>
-      </p:sp>
-      <p:sp>
-        <p:nvSpPr>
-          <p:cNvPr id="29" name="Rounded Rectangle 28"/>
-          <p:cNvSpPr/>
-          <p:nvPr/>
-        </p:nvSpPr>
-        <p:spPr>
-          <a:xfrm>
-            <a:off x="6309359" y="4480560"/>
-            <a:ext cx="2651760" cy="2011680"/>
-          </a:xfrm>
-          <a:prstGeom prst="roundRect">
-            <a:avLst/>
-          </a:prstGeom>
-          <a:solidFill>
-            <a:srgbClr val="FFFFFF"/>
-          </a:solidFill>
-          <a:ln w="19050">
-            <a:solidFill>
-              <a:srgbClr val="D4A017"/>
-            </a:solidFill>
-          </a:ln>
-        </p:spPr>
-        <p:style>
-          <a:lnRef idx="1">
-            <a:schemeClr val="accent1"/>
-          </a:lnRef>
-          <a:fillRef idx="3">
-            <a:schemeClr val="accent1"/>
-          </a:fillRef>
-          <a:effectRef idx="2">
-            <a:schemeClr val="accent1"/>
-          </a:effectRef>
-          <a:fontRef idx="minor">
-            <a:schemeClr val="lt1"/>
-          </a:fontRef>
-        </p:style>
-        <p:txBody>
-          <a:bodyPr rtlCol="0" anchor="ctr"/>
-          <a:lstStyle/>
-          <a:p>
-            <a:pPr algn="ctr"/>
-            <a:endParaRPr/>
-          </a:p>
-        </p:txBody>
-      </p:sp>
-      <p:sp>
-        <p:nvSpPr>
-          <p:cNvPr id="30" name="Oval 29"/>
-          <p:cNvSpPr/>
-          <p:nvPr/>
-        </p:nvSpPr>
-        <p:spPr>
-          <a:xfrm>
-            <a:off x="6446519" y="4617720"/>
-            <a:ext cx="502920" cy="502920"/>
-          </a:xfrm>
-          <a:prstGeom prst="ellipse">
-            <a:avLst/>
-          </a:prstGeom>
-          <a:solidFill>
-            <a:srgbClr val="D4A017"/>
-          </a:solidFill>
-          <a:ln>
-            <a:noFill/>
-          </a:ln>
-        </p:spPr>
-        <p:style>
-          <a:lnRef idx="1">
-            <a:schemeClr val="accent1"/>
-          </a:lnRef>
-          <a:fillRef idx="3">
-            <a:schemeClr val="accent1"/>
-          </a:fillRef>
-          <a:effectRef idx="2">
-            <a:schemeClr val="accent1"/>
-          </a:effectRef>
-          <a:fontRef idx="minor">
-            <a:schemeClr val="lt1"/>
-          </a:fontRef>
-        </p:style>
-        <p:txBody>
-          <a:bodyPr rtlCol="0" anchor="ctr"/>
-          <a:lstStyle/>
-          <a:p>
-            <a:pPr algn="ctr">
-              <a:defRPr sz="1800">
-                <a:solidFill>
-                  <a:srgbClr val="FFFFFF"/>
-                </a:solidFill>
-              </a:defRPr>
-            </a:pPr>
-            <a:r>
-              <a:t>🔄</a:t>
-            </a:r>
-          </a:p>
-        </p:txBody>
-      </p:sp>
-      <p:sp>
-        <p:nvSpPr>
-          <p:cNvPr id="31" name="TextBox 30"/>
-          <p:cNvSpPr txBox="1"/>
-          <p:nvPr/>
-        </p:nvSpPr>
-        <p:spPr>
-          <a:xfrm>
-            <a:off x="7040879" y="4663440"/>
-            <a:ext cx="1737360" cy="320040"/>
-          </a:xfrm>
-          <a:prstGeom prst="rect">
-            <a:avLst/>
-          </a:prstGeom>
-          <a:noFill/>
-        </p:spPr>
-        <p:txBody>
-          <a:bodyPr wrap="square">
-            <a:spAutoFit/>
-          </a:bodyPr>
-          <a:lstStyle/>
-          <a:p>
-            <a:pPr algn="l">
-              <a:defRPr sz="1400" b="1">
-                <a:solidFill>
-                  <a:srgbClr val="D4A017"/>
-                </a:solidFill>
-              </a:defRPr>
-            </a:pPr>
-            <a:r>
-              <a:t>Turnover</a:t>
-            </a:r>
-          </a:p>
-        </p:txBody>
-      </p:sp>
-      <p:sp>
-        <p:nvSpPr>
-          <p:cNvPr id="32" name="TextBox 31"/>
-          <p:cNvSpPr txBox="1"/>
-          <p:nvPr/>
-        </p:nvSpPr>
-        <p:spPr>
-          <a:xfrm>
-            <a:off x="6492239" y="5212080"/>
-            <a:ext cx="2286000" cy="1097280"/>
-          </a:xfrm>
-          <a:prstGeom prst="rect">
-            <a:avLst/>
-          </a:prstGeom>
-          <a:noFill/>
-        </p:spPr>
-        <p:txBody>
-          <a:bodyPr wrap="square">
-            <a:spAutoFit/>
-          </a:bodyPr>
-          <a:lstStyle/>
-          <a:p>
-            <a:pPr algn="ctr">
-              <a:defRPr sz="1200" b="0">
-                <a:solidFill>
-                  <a:srgbClr val="2D3A4A"/>
-                </a:solidFill>
-              </a:defRPr>
-            </a:pPr>
-            <a:r>
-              <a:t>Gen Z so sánh tổng</a:t>
-            </a:r>
-            <a:br/>
-            <a:r>
-              <a:t>thu nhập sau chi phí</a:t>
             </a:r>
           </a:p>
         </p:txBody>
@@ -9876,7 +8740,7 @@
         </p:nvSpPr>
         <p:spPr>
           <a:xfrm>
-            <a:off x="9189719" y="4480560"/>
+            <a:off x="7406639" y="4404945"/>
             <a:ext cx="2651760" cy="2011680"/>
           </a:xfrm>
           <a:prstGeom prst="roundRect">
@@ -9922,7 +8786,7 @@
         </p:nvSpPr>
         <p:spPr>
           <a:xfrm>
-            <a:off x="9326879" y="4617720"/>
+            <a:off x="7543799" y="4542105"/>
             <a:ext cx="502920" cy="502920"/>
           </a:xfrm>
           <a:prstGeom prst="ellipse">
@@ -9974,7 +8838,7 @@
         </p:nvSpPr>
         <p:spPr>
           <a:xfrm>
-            <a:off x="9921239" y="4663440"/>
+            <a:off x="8138159" y="4587825"/>
             <a:ext cx="1737360" cy="320040"/>
           </a:xfrm>
           <a:prstGeom prst="rect">
@@ -10009,7 +8873,7 @@
         </p:nvSpPr>
         <p:spPr>
           <a:xfrm>
-            <a:off x="9372599" y="5212080"/>
+            <a:off x="7589519" y="5136465"/>
             <a:ext cx="2286000" cy="1097280"/>
           </a:xfrm>
           <a:prstGeom prst="rect">
@@ -10160,7 +9024,7 @@
         </p:nvSpPr>
         <p:spPr>
           <a:xfrm>
-            <a:off x="365760" y="1645920"/>
+            <a:off x="1551792" y="1651300"/>
             <a:ext cx="1920240" cy="1828800"/>
           </a:xfrm>
           <a:prstGeom prst="roundRect">
@@ -10206,7 +9070,7 @@
         </p:nvSpPr>
         <p:spPr>
           <a:xfrm>
-            <a:off x="960120" y="1828800"/>
+            <a:off x="2146152" y="1834180"/>
             <a:ext cx="640080" cy="640080"/>
           </a:xfrm>
           <a:prstGeom prst="ellipse">
@@ -10258,7 +9122,7 @@
         </p:nvSpPr>
         <p:spPr>
           <a:xfrm>
-            <a:off x="457200" y="2606040"/>
+            <a:off x="1643232" y="2611420"/>
             <a:ext cx="1737360" cy="731520"/>
           </a:xfrm>
           <a:prstGeom prst="rect">
@@ -10297,7 +9161,7 @@
         </p:nvSpPr>
         <p:spPr>
           <a:xfrm>
-            <a:off x="2240279" y="2194560"/>
+            <a:off x="3426311" y="2199940"/>
             <a:ext cx="457200" cy="457200"/>
           </a:xfrm>
           <a:prstGeom prst="rect">
@@ -10332,7 +9196,7 @@
         </p:nvSpPr>
         <p:spPr>
           <a:xfrm>
-            <a:off x="2743200" y="1645920"/>
+            <a:off x="3929232" y="1651300"/>
             <a:ext cx="1920240" cy="1828800"/>
           </a:xfrm>
           <a:prstGeom prst="roundRect">
@@ -10378,7 +9242,7 @@
         </p:nvSpPr>
         <p:spPr>
           <a:xfrm>
-            <a:off x="3337560" y="1828800"/>
+            <a:off x="4523592" y="1834180"/>
             <a:ext cx="640080" cy="640080"/>
           </a:xfrm>
           <a:prstGeom prst="ellipse">
@@ -10430,7 +9294,7 @@
         </p:nvSpPr>
         <p:spPr>
           <a:xfrm>
-            <a:off x="2834640" y="2606040"/>
+            <a:off x="4020672" y="2611420"/>
             <a:ext cx="1737360" cy="731520"/>
           </a:xfrm>
           <a:prstGeom prst="rect">
@@ -10502,7 +9366,7 @@
         </p:nvSpPr>
         <p:spPr>
           <a:xfrm>
-            <a:off x="4617719" y="2194560"/>
+            <a:off x="5803751" y="2199940"/>
             <a:ext cx="457200" cy="457200"/>
           </a:xfrm>
           <a:prstGeom prst="rect">
@@ -10537,7 +9401,7 @@
         </p:nvSpPr>
         <p:spPr>
           <a:xfrm>
-            <a:off x="5120640" y="1645920"/>
+            <a:off x="6306672" y="1651300"/>
             <a:ext cx="1920240" cy="1828800"/>
           </a:xfrm>
           <a:prstGeom prst="roundRect">
@@ -10583,7 +9447,7 @@
         </p:nvSpPr>
         <p:spPr>
           <a:xfrm>
-            <a:off x="5715000" y="1828800"/>
+            <a:off x="6901032" y="1834180"/>
             <a:ext cx="640080" cy="640080"/>
           </a:xfrm>
           <a:prstGeom prst="ellipse">
@@ -10635,7 +9499,7 @@
         </p:nvSpPr>
         <p:spPr>
           <a:xfrm>
-            <a:off x="5212080" y="2606040"/>
+            <a:off x="6398112" y="2611420"/>
             <a:ext cx="1737360" cy="731520"/>
           </a:xfrm>
           <a:prstGeom prst="rect">
@@ -10674,7 +9538,7 @@
         </p:nvSpPr>
         <p:spPr>
           <a:xfrm>
-            <a:off x="6995159" y="2194560"/>
+            <a:off x="8181191" y="2199940"/>
             <a:ext cx="457200" cy="457200"/>
           </a:xfrm>
           <a:prstGeom prst="rect">
@@ -10703,185 +9567,13 @@
       </p:sp>
       <p:sp>
         <p:nvSpPr>
-          <p:cNvPr id="16" name="Rounded Rectangle 15"/>
-          <p:cNvSpPr/>
-          <p:nvPr/>
-        </p:nvSpPr>
-        <p:spPr>
-          <a:xfrm>
-            <a:off x="7498080" y="1645920"/>
-            <a:ext cx="1920240" cy="1828800"/>
-          </a:xfrm>
-          <a:prstGeom prst="roundRect">
-            <a:avLst/>
-          </a:prstGeom>
-          <a:solidFill>
-            <a:srgbClr val="FFFFFF"/>
-          </a:solidFill>
-          <a:ln w="19050">
-            <a:solidFill>
-              <a:srgbClr val="2E86AB"/>
-            </a:solidFill>
-          </a:ln>
-        </p:spPr>
-        <p:style>
-          <a:lnRef idx="1">
-            <a:schemeClr val="accent1"/>
-          </a:lnRef>
-          <a:fillRef idx="3">
-            <a:schemeClr val="accent1"/>
-          </a:fillRef>
-          <a:effectRef idx="2">
-            <a:schemeClr val="accent1"/>
-          </a:effectRef>
-          <a:fontRef idx="minor">
-            <a:schemeClr val="lt1"/>
-          </a:fontRef>
-        </p:style>
-        <p:txBody>
-          <a:bodyPr rtlCol="0" anchor="ctr"/>
-          <a:lstStyle/>
-          <a:p>
-            <a:pPr algn="ctr"/>
-            <a:endParaRPr/>
-          </a:p>
-        </p:txBody>
-      </p:sp>
-      <p:sp>
-        <p:nvSpPr>
-          <p:cNvPr id="17" name="Oval 16"/>
-          <p:cNvSpPr/>
-          <p:nvPr/>
-        </p:nvSpPr>
-        <p:spPr>
-          <a:xfrm>
-            <a:off x="8092440" y="1828800"/>
-            <a:ext cx="640080" cy="640080"/>
-          </a:xfrm>
-          <a:prstGeom prst="ellipse">
-            <a:avLst/>
-          </a:prstGeom>
-          <a:solidFill>
-            <a:srgbClr val="2E86AB"/>
-          </a:solidFill>
-          <a:ln>
-            <a:noFill/>
-          </a:ln>
-        </p:spPr>
-        <p:style>
-          <a:lnRef idx="1">
-            <a:schemeClr val="accent1"/>
-          </a:lnRef>
-          <a:fillRef idx="3">
-            <a:schemeClr val="accent1"/>
-          </a:fillRef>
-          <a:effectRef idx="2">
-            <a:schemeClr val="accent1"/>
-          </a:effectRef>
-          <a:fontRef idx="minor">
-            <a:schemeClr val="lt1"/>
-          </a:fontRef>
-        </p:style>
-        <p:txBody>
-          <a:bodyPr rtlCol="0" anchor="ctr"/>
-          <a:lstStyle/>
-          <a:p>
-            <a:pPr algn="ctr">
-              <a:defRPr sz="2000">
-                <a:solidFill>
-                  <a:srgbClr val="FFFFFF"/>
-                </a:solidFill>
-              </a:defRPr>
-            </a:pPr>
-            <a:r>
-              <a:t>📋</a:t>
-            </a:r>
-          </a:p>
-        </p:txBody>
-      </p:sp>
-      <p:sp>
-        <p:nvSpPr>
-          <p:cNvPr id="18" name="TextBox 17"/>
-          <p:cNvSpPr txBox="1"/>
-          <p:nvPr/>
-        </p:nvSpPr>
-        <p:spPr>
-          <a:xfrm>
-            <a:off x="7589520" y="2606040"/>
-            <a:ext cx="1737360" cy="731520"/>
-          </a:xfrm>
-          <a:prstGeom prst="rect">
-            <a:avLst/>
-          </a:prstGeom>
-          <a:noFill/>
-        </p:spPr>
-        <p:txBody>
-          <a:bodyPr wrap="square">
-            <a:spAutoFit/>
-          </a:bodyPr>
-          <a:lstStyle/>
-          <a:p>
-            <a:pPr algn="ctr">
-              <a:defRPr sz="1200" b="1">
-                <a:solidFill>
-                  <a:srgbClr val="2E86AB"/>
-                </a:solidFill>
-              </a:defRPr>
-            </a:pPr>
-            <a:r>
-              <a:t>Ít bản vẽ</a:t>
-            </a:r>
-            <a:br/>
-            <a:r>
-              <a:t>cho công ty mẹ</a:t>
-            </a:r>
-          </a:p>
-        </p:txBody>
-      </p:sp>
-      <p:sp>
-        <p:nvSpPr>
-          <p:cNvPr id="19" name="TextBox 18"/>
-          <p:cNvSpPr txBox="1"/>
-          <p:nvPr/>
-        </p:nvSpPr>
-        <p:spPr>
-          <a:xfrm>
-            <a:off x="9372599" y="2194560"/>
-            <a:ext cx="457200" cy="457200"/>
-          </a:xfrm>
-          <a:prstGeom prst="rect">
-            <a:avLst/>
-          </a:prstGeom>
-          <a:noFill/>
-        </p:spPr>
-        <p:txBody>
-          <a:bodyPr wrap="square">
-            <a:spAutoFit/>
-          </a:bodyPr>
-          <a:lstStyle/>
-          <a:p>
-            <a:pPr algn="ctr">
-              <a:defRPr sz="2400" b="1">
-                <a:solidFill>
-                  <a:srgbClr val="7F8C8D"/>
-                </a:solidFill>
-              </a:defRPr>
-            </a:pPr>
-            <a:r>
-              <a:t>→</a:t>
-            </a:r>
-          </a:p>
-        </p:txBody>
-      </p:sp>
-      <p:sp>
-        <p:nvSpPr>
           <p:cNvPr id="20" name="Rounded Rectangle 19"/>
           <p:cNvSpPr/>
           <p:nvPr/>
         </p:nvSpPr>
         <p:spPr>
           <a:xfrm>
-            <a:off x="9875520" y="1645920"/>
+            <a:off x="8638391" y="1645920"/>
             <a:ext cx="1920240" cy="1828800"/>
           </a:xfrm>
           <a:prstGeom prst="roundRect">
@@ -10927,7 +9619,7 @@
         </p:nvSpPr>
         <p:spPr>
           <a:xfrm>
-            <a:off x="10469880" y="1828800"/>
+            <a:off x="9232751" y="1828800"/>
             <a:ext cx="640080" cy="640080"/>
           </a:xfrm>
           <a:prstGeom prst="ellipse">
@@ -10979,7 +9671,7 @@
         </p:nvSpPr>
         <p:spPr>
           <a:xfrm>
-            <a:off x="9966960" y="2606040"/>
+            <a:off x="8729831" y="2606040"/>
             <a:ext cx="1737360" cy="731520"/>
           </a:xfrm>
           <a:prstGeom prst="rect">
@@ -11053,7 +9745,7 @@
         </p:nvSpPr>
         <p:spPr>
           <a:xfrm>
-            <a:off x="548640" y="4389120"/>
+            <a:off x="2560320" y="4434840"/>
             <a:ext cx="3520440" cy="2011680"/>
           </a:xfrm>
           <a:prstGeom prst="roundRect">
@@ -11099,7 +9791,7 @@
         </p:nvSpPr>
         <p:spPr>
           <a:xfrm>
-            <a:off x="731520" y="4526280"/>
+            <a:off x="2743200" y="4572000"/>
             <a:ext cx="3154680" cy="320040"/>
           </a:xfrm>
           <a:prstGeom prst="rect">
@@ -11134,7 +9826,7 @@
         </p:nvSpPr>
         <p:spPr>
           <a:xfrm>
-            <a:off x="731520" y="4937760"/>
+            <a:off x="2743200" y="4983480"/>
             <a:ext cx="3154680" cy="1280160"/>
           </a:xfrm>
           <a:prstGeom prst="rect">
@@ -11177,7 +9869,7 @@
         </p:nvSpPr>
         <p:spPr>
           <a:xfrm>
-            <a:off x="4343400" y="4389120"/>
+            <a:off x="6355080" y="4434840"/>
             <a:ext cx="3520440" cy="2011680"/>
           </a:xfrm>
           <a:prstGeom prst="roundRect">
@@ -11223,7 +9915,7 @@
         </p:nvSpPr>
         <p:spPr>
           <a:xfrm>
-            <a:off x="4526280" y="4526280"/>
+            <a:off x="6537960" y="4572000"/>
             <a:ext cx="3154680" cy="320040"/>
           </a:xfrm>
           <a:prstGeom prst="rect">
@@ -11258,7 +9950,7 @@
         </p:nvSpPr>
         <p:spPr>
           <a:xfrm>
-            <a:off x="4526280" y="4937760"/>
+            <a:off x="6537960" y="4983480"/>
             <a:ext cx="3154680" cy="1280160"/>
           </a:xfrm>
           <a:prstGeom prst="rect">
@@ -11289,130 +9981,6 @@
             <a:br/>
             <a:r>
               <a:t>và KPI headcount</a:t>
-            </a:r>
-          </a:p>
-        </p:txBody>
-      </p:sp>
-      <p:sp>
-        <p:nvSpPr>
-          <p:cNvPr id="30" name="Rounded Rectangle 29"/>
-          <p:cNvSpPr/>
-          <p:nvPr/>
-        </p:nvSpPr>
-        <p:spPr>
-          <a:xfrm>
-            <a:off x="8138160" y="4389120"/>
-            <a:ext cx="3520440" cy="2011680"/>
-          </a:xfrm>
-          <a:prstGeom prst="roundRect">
-            <a:avLst/>
-          </a:prstGeom>
-          <a:solidFill>
-            <a:srgbClr val="FFFFFF"/>
-          </a:solidFill>
-          <a:ln w="19050">
-            <a:solidFill>
-              <a:srgbClr val="1B3A5C"/>
-            </a:solidFill>
-          </a:ln>
-        </p:spPr>
-        <p:style>
-          <a:lnRef idx="1">
-            <a:schemeClr val="accent1"/>
-          </a:lnRef>
-          <a:fillRef idx="3">
-            <a:schemeClr val="accent1"/>
-          </a:fillRef>
-          <a:effectRef idx="2">
-            <a:schemeClr val="accent1"/>
-          </a:effectRef>
-          <a:fontRef idx="minor">
-            <a:schemeClr val="lt1"/>
-          </a:fontRef>
-        </p:style>
-        <p:txBody>
-          <a:bodyPr rtlCol="0" anchor="ctr"/>
-          <a:lstStyle/>
-          <a:p>
-            <a:pPr algn="ctr"/>
-            <a:endParaRPr/>
-          </a:p>
-        </p:txBody>
-      </p:sp>
-      <p:sp>
-        <p:nvSpPr>
-          <p:cNvPr id="31" name="TextBox 30"/>
-          <p:cNvSpPr txBox="1"/>
-          <p:nvPr/>
-        </p:nvSpPr>
-        <p:spPr>
-          <a:xfrm>
-            <a:off x="8321040" y="4526280"/>
-            <a:ext cx="3154680" cy="320040"/>
-          </a:xfrm>
-          <a:prstGeom prst="rect">
-            <a:avLst/>
-          </a:prstGeom>
-          <a:noFill/>
-        </p:spPr>
-        <p:txBody>
-          <a:bodyPr wrap="square">
-            <a:spAutoFit/>
-          </a:bodyPr>
-          <a:lstStyle/>
-          <a:p>
-            <a:pPr algn="l">
-              <a:defRPr sz="1400" b="1">
-                <a:solidFill>
-                  <a:srgbClr val="1B3A5C"/>
-                </a:solidFill>
-              </a:defRPr>
-            </a:pPr>
-            <a:r>
-              <a:t>Nhân viên Gen Z</a:t>
-            </a:r>
-          </a:p>
-        </p:txBody>
-      </p:sp>
-      <p:sp>
-        <p:nvSpPr>
-          <p:cNvPr id="32" name="TextBox 31"/>
-          <p:cNvSpPr txBox="1"/>
-          <p:nvPr/>
-        </p:nvSpPr>
-        <p:spPr>
-          <a:xfrm>
-            <a:off x="8321040" y="4937760"/>
-            <a:ext cx="3154680" cy="1280160"/>
-          </a:xfrm>
-          <a:prstGeom prst="rect">
-            <a:avLst/>
-          </a:prstGeom>
-          <a:noFill/>
-        </p:spPr>
-        <p:txBody>
-          <a:bodyPr wrap="square">
-            <a:spAutoFit/>
-          </a:bodyPr>
-          <a:lstStyle/>
-          <a:p>
-            <a:pPr algn="l">
-              <a:defRPr sz="1200" b="0">
-                <a:solidFill>
-                  <a:srgbClr val="2D3A4A"/>
-                </a:solidFill>
-              </a:defRPr>
-            </a:pPr>
-            <a:r>
-              <a:t>Vay mua nhà/xe lãi suất cao</a:t>
-            </a:r>
-            <a:br/>
-            <a:r>
-              <a:t>→ Áp lực tài chính cá nhân</a:t>
-            </a:r>
-            <a:br/>
-            <a:r>
-              <a:t>→ Giảm hiệu suất, tăng turnover</a:t>
             </a:r>
           </a:p>
         </p:txBody>
@@ -11840,7 +10408,7 @@
         <p:spPr>
           <a:xfrm>
             <a:off x="6583680" y="2057400"/>
-            <a:ext cx="4754880" cy="365760"/>
+            <a:ext cx="4754880" cy="292388"/>
           </a:xfrm>
           <a:prstGeom prst="rect">
             <a:avLst/>
@@ -11861,8 +10429,70 @@
               </a:defRPr>
             </a:pPr>
             <a:r>
-              <a:t>✓ Đã có năng lực BIM theo chuẩn quốc tế (Đức)</a:t>
-            </a:r>
+              <a:rPr dirty="0"/>
+              <a:t>✓ </a:t>
+            </a:r>
+            <a:r>
+              <a:rPr dirty="0" err="1"/>
+              <a:t>Đã</a:t>
+            </a:r>
+            <a:r>
+              <a:rPr dirty="0"/>
+              <a:t> </a:t>
+            </a:r>
+            <a:r>
+              <a:rPr dirty="0" err="1"/>
+              <a:t>có</a:t>
+            </a:r>
+            <a:r>
+              <a:rPr dirty="0"/>
+              <a:t> </a:t>
+            </a:r>
+            <a:r>
+              <a:rPr dirty="0" err="1"/>
+              <a:t>năng</a:t>
+            </a:r>
+            <a:r>
+              <a:rPr dirty="0"/>
+              <a:t> </a:t>
+            </a:r>
+            <a:r>
+              <a:rPr dirty="0" err="1"/>
+              <a:t>lực</a:t>
+            </a:r>
+            <a:r>
+              <a:rPr dirty="0"/>
+              <a:t> BIM </a:t>
+            </a:r>
+            <a:r>
+              <a:rPr dirty="0" err="1"/>
+              <a:t>theo</a:t>
+            </a:r>
+            <a:r>
+              <a:rPr dirty="0"/>
+              <a:t> </a:t>
+            </a:r>
+            <a:r>
+              <a:rPr dirty="0" err="1"/>
+              <a:t>chuẩn</a:t>
+            </a:r>
+            <a:r>
+              <a:rPr dirty="0"/>
+              <a:t> </a:t>
+            </a:r>
+            <a:r>
+              <a:rPr dirty="0" err="1"/>
+              <a:t>quốc</a:t>
+            </a:r>
+            <a:r>
+              <a:rPr dirty="0"/>
+              <a:t> </a:t>
+            </a:r>
+            <a:r>
+              <a:rPr dirty="0" err="1"/>
+              <a:t>tế</a:t>
+            </a:r>
+            <a:endParaRPr dirty="0"/>
           </a:p>
         </p:txBody>
       </p:sp>
@@ -11931,43 +10561,62 @@
               </a:defRPr>
             </a:pPr>
             <a:r>
-              <a:t>✓ Nhu cầu thuê ngoài dịch vụ BIM tăng cao</a:t>
-            </a:r>
-          </a:p>
-        </p:txBody>
-      </p:sp>
-      <p:sp>
-        <p:nvSpPr>
-          <p:cNvPr id="15" name="TextBox 14"/>
-          <p:cNvSpPr txBox="1"/>
-          <p:nvPr/>
-        </p:nvSpPr>
-        <p:spPr>
-          <a:xfrm>
-            <a:off x="6583680" y="3291840"/>
-            <a:ext cx="4754880" cy="365760"/>
-          </a:xfrm>
-          <a:prstGeom prst="rect">
-            <a:avLst/>
-          </a:prstGeom>
-          <a:noFill/>
-        </p:spPr>
-        <p:txBody>
-          <a:bodyPr wrap="square">
-            <a:spAutoFit/>
-          </a:bodyPr>
-          <a:lstStyle/>
-          <a:p>
-            <a:pPr algn="l">
-              <a:defRPr sz="1300" b="0">
-                <a:solidFill>
-                  <a:srgbClr val="2D3A4A"/>
-                </a:solidFill>
-              </a:defRPr>
-            </a:pPr>
-            <a:r>
-              <a:t>✓ Gen Z = digital native → R&amp;D BIM nội bộ</a:t>
-            </a:r>
+              <a:rPr dirty="0"/>
+              <a:t>✓ Nhu </a:t>
+            </a:r>
+            <a:r>
+              <a:rPr dirty="0" err="1"/>
+              <a:t>cầu</a:t>
+            </a:r>
+            <a:r>
+              <a:rPr dirty="0"/>
+              <a:t> </a:t>
+            </a:r>
+            <a:r>
+              <a:rPr dirty="0" err="1"/>
+              <a:t>thuê</a:t>
+            </a:r>
+            <a:r>
+              <a:rPr dirty="0"/>
+              <a:t> </a:t>
+            </a:r>
+            <a:r>
+              <a:rPr dirty="0" err="1"/>
+              <a:t>ngoài</a:t>
+            </a:r>
+            <a:r>
+              <a:rPr dirty="0"/>
+              <a:t> </a:t>
+            </a:r>
+            <a:r>
+              <a:rPr dirty="0" err="1"/>
+              <a:t>dịch</a:t>
+            </a:r>
+            <a:r>
+              <a:rPr dirty="0"/>
+              <a:t> </a:t>
+            </a:r>
+            <a:r>
+              <a:rPr dirty="0" err="1"/>
+              <a:t>vụ</a:t>
+            </a:r>
+            <a:r>
+              <a:rPr dirty="0"/>
+              <a:t> BIM </a:t>
+            </a:r>
+            <a:r>
+              <a:rPr dirty="0" err="1"/>
+              <a:t>tăng</a:t>
+            </a:r>
+            <a:r>
+              <a:rPr dirty="0"/>
+              <a:t> </a:t>
+            </a:r>
+            <a:r>
+              <a:rPr dirty="0" err="1"/>
+              <a:t>cao</a:t>
+            </a:r>
+            <a:endParaRPr dirty="0"/>
           </a:p>
         </p:txBody>
       </p:sp>
@@ -12134,8 +10783,14 @@
               </a:defRPr>
             </a:pPr>
             <a:r>
-              <a:t>Định vị dẫn đầu</a:t>
-            </a:r>
+              <a:rPr dirty="0"/>
+              <a:t>Định </a:t>
+            </a:r>
+            <a:r>
+              <a:rPr dirty="0" err="1"/>
+              <a:t>vị</a:t>
+            </a:r>
+            <a:endParaRPr dirty="0"/>
           </a:p>
         </p:txBody>
       </p:sp>
@@ -12169,11 +10824,19 @@
               </a:defRPr>
             </a:pPr>
             <a:r>
+              <a:rPr dirty="0"/>
               <a:t>BIM outsourcing</a:t>
             </a:r>
-            <a:br/>
-            <a:r>
-              <a:t>tại Việt Nam</a:t>
+            <a:br>
+              <a:rPr dirty="0"/>
+            </a:br>
+            <a:r>
+              <a:rPr dirty="0" err="1"/>
+              <a:t>tại</a:t>
+            </a:r>
+            <a:r>
+              <a:rPr dirty="0"/>
+              <a:t> Việt Nam</a:t>
             </a:r>
           </a:p>
         </p:txBody>
@@ -12320,7 +10983,7 @@
         <p:spPr>
           <a:xfrm>
             <a:off x="3611880" y="5303520"/>
-            <a:ext cx="2286000" cy="914400"/>
+            <a:ext cx="2286000" cy="461665"/>
           </a:xfrm>
           <a:prstGeom prst="rect">
             <a:avLst/>
@@ -12341,11 +11004,63 @@
               </a:defRPr>
             </a:pPr>
             <a:r>
-              <a:t>Chuyển giao quy trình</a:t>
-            </a:r>
-            <a:br/>
-            <a:r>
-              <a:t>Đức → gói dịch vụ VN</a:t>
+              <a:rPr dirty="0" err="1"/>
+              <a:t>Chuyển</a:t>
+            </a:r>
+            <a:r>
+              <a:rPr dirty="0"/>
+              <a:t> </a:t>
+            </a:r>
+            <a:r>
+              <a:rPr dirty="0" err="1"/>
+              <a:t>giao</a:t>
+            </a:r>
+            <a:r>
+              <a:rPr dirty="0"/>
+              <a:t> </a:t>
+            </a:r>
+            <a:r>
+              <a:rPr dirty="0" err="1"/>
+              <a:t>quy</a:t>
+            </a:r>
+            <a:r>
+              <a:rPr dirty="0"/>
+              <a:t> </a:t>
+            </a:r>
+            <a:r>
+              <a:rPr dirty="0" err="1"/>
+              <a:t>trình</a:t>
+            </a:r>
+            <a:br>
+              <a:rPr dirty="0"/>
+            </a:br>
+            <a:r>
+              <a:rPr dirty="0"/>
+              <a:t> → </a:t>
+            </a:r>
+            <a:r>
+              <a:rPr dirty="0" err="1"/>
+              <a:t>gói</a:t>
+            </a:r>
+            <a:r>
+              <a:rPr dirty="0"/>
+              <a:t> </a:t>
+            </a:r>
+            <a:r>
+              <a:rPr dirty="0" err="1"/>
+              <a:t>dịch</a:t>
+            </a:r>
+            <a:r>
+              <a:rPr dirty="0"/>
+              <a:t> </a:t>
+            </a:r>
+            <a:r>
+              <a:rPr dirty="0" err="1"/>
+              <a:t>vụ</a:t>
+            </a:r>
+            <a:r>
+              <a:rPr dirty="0"/>
+              <a:t> VN</a:t>
             </a:r>
           </a:p>
         </p:txBody>
@@ -12685,12 +11400,49 @@
               </a:defRPr>
             </a:pPr>
             <a:r>
-              <a:t>Local GC, chủ đầu tư</a:t>
-            </a:r>
-            <a:br/>
-            <a:r>
-              <a:t>consultant nội địa</a:t>
-            </a:r>
+              <a:rPr dirty="0"/>
+              <a:t>Local GC, </a:t>
+            </a:r>
+            <a:r>
+              <a:rPr dirty="0" err="1"/>
+              <a:t>chủ</a:t>
+            </a:r>
+            <a:r>
+              <a:rPr dirty="0"/>
+              <a:t> </a:t>
+            </a:r>
+            <a:r>
+              <a:rPr dirty="0" err="1"/>
+              <a:t>đầu</a:t>
+            </a:r>
+            <a:r>
+              <a:rPr dirty="0"/>
+              <a:t> </a:t>
+            </a:r>
+            <a:r>
+              <a:rPr dirty="0" err="1"/>
+              <a:t>tư</a:t>
+            </a:r>
+            <a:br>
+              <a:rPr dirty="0"/>
+            </a:br>
+            <a:r>
+              <a:rPr dirty="0"/>
+              <a:t>consultant </a:t>
+            </a:r>
+            <a:r>
+              <a:rPr dirty="0" err="1"/>
+              <a:t>nội</a:t>
+            </a:r>
+            <a:r>
+              <a:rPr dirty="0"/>
+              <a:t> </a:t>
+            </a:r>
+            <a:r>
+              <a:rPr dirty="0" err="1"/>
+              <a:t>địa</a:t>
+            </a:r>
+            <a:endParaRPr dirty="0"/>
           </a:p>
         </p:txBody>
       </p:sp>
@@ -14410,7 +13162,7 @@
         <p:spPr>
           <a:xfrm>
             <a:off x="3840480" y="2468880"/>
-            <a:ext cx="2011680" cy="548640"/>
+            <a:ext cx="2011680" cy="276999"/>
           </a:xfrm>
           <a:prstGeom prst="rect">
             <a:avLst/>
@@ -14431,7 +13183,20 @@
               </a:defRPr>
             </a:pPr>
             <a:r>
-              <a:t>Chính sách hybrid (2-3 ngày WFH)</a:t>
+              <a:rPr dirty="0" err="1"/>
+              <a:t>Chính</a:t>
+            </a:r>
+            <a:r>
+              <a:rPr dirty="0"/>
+              <a:t> </a:t>
+            </a:r>
+            <a:r>
+              <a:rPr dirty="0" err="1"/>
+              <a:t>sách</a:t>
+            </a:r>
+            <a:r>
+              <a:rPr dirty="0"/>
+              <a:t> hybrid (WFH)</a:t>
             </a:r>
           </a:p>
         </p:txBody>
@@ -14482,13 +13247,13 @@
       </p:sp>
       <p:sp>
         <p:nvSpPr>
-          <p:cNvPr id="23" name="TextBox 22"/>
+          <p:cNvPr id="25" name="TextBox 24"/>
           <p:cNvSpPr txBox="1"/>
           <p:nvPr/>
         </p:nvSpPr>
         <p:spPr>
           <a:xfrm>
-            <a:off x="3840480" y="3108960"/>
+            <a:off x="3840480" y="3039708"/>
             <a:ext cx="2011680" cy="548640"/>
           </a:xfrm>
           <a:prstGeom prst="rect">
@@ -14510,87 +13275,66 @@
               </a:defRPr>
             </a:pPr>
             <a:r>
-              <a:t>Hỗ trợ vé xe buýt / metro</a:t>
-            </a:r>
-          </a:p>
-        </p:txBody>
-      </p:sp>
-      <p:sp>
-        <p:nvSpPr>
-          <p:cNvPr id="24" name="Oval 23"/>
-          <p:cNvSpPr/>
-          <p:nvPr/>
-        </p:nvSpPr>
-        <p:spPr>
-          <a:xfrm>
-            <a:off x="3566160" y="3794760"/>
-            <a:ext cx="164592" cy="164592"/>
-          </a:xfrm>
-          <a:prstGeom prst="ellipse">
-            <a:avLst/>
-          </a:prstGeom>
-          <a:solidFill>
-            <a:srgbClr val="E86C00"/>
-          </a:solidFill>
-          <a:ln>
-            <a:noFill/>
-          </a:ln>
-        </p:spPr>
-        <p:style>
-          <a:lnRef idx="1">
-            <a:schemeClr val="accent1"/>
-          </a:lnRef>
-          <a:fillRef idx="3">
-            <a:schemeClr val="accent1"/>
-          </a:fillRef>
-          <a:effectRef idx="2">
-            <a:schemeClr val="accent1"/>
-          </a:effectRef>
-          <a:fontRef idx="minor">
-            <a:schemeClr val="lt1"/>
-          </a:fontRef>
-        </p:style>
-        <p:txBody>
-          <a:bodyPr rtlCol="0" anchor="ctr"/>
-          <a:lstStyle/>
-          <a:p>
-            <a:pPr algn="ctr"/>
-            <a:endParaRPr/>
-          </a:p>
-        </p:txBody>
-      </p:sp>
-      <p:sp>
-        <p:nvSpPr>
-          <p:cNvPr id="25" name="TextBox 24"/>
-          <p:cNvSpPr txBox="1"/>
-          <p:nvPr/>
-        </p:nvSpPr>
-        <p:spPr>
-          <a:xfrm>
-            <a:off x="3840480" y="3749040"/>
-            <a:ext cx="2011680" cy="548640"/>
-          </a:xfrm>
-          <a:prstGeom prst="rect">
-            <a:avLst/>
-          </a:prstGeom>
-          <a:noFill/>
-        </p:spPr>
-        <p:txBody>
-          <a:bodyPr wrap="square">
-            <a:spAutoFit/>
-          </a:bodyPr>
-          <a:lstStyle/>
-          <a:p>
-            <a:pPr algn="l">
-              <a:defRPr sz="1200" b="0">
-                <a:solidFill>
-                  <a:srgbClr val="2D3A4A"/>
-                </a:solidFill>
-              </a:defRPr>
-            </a:pPr>
-            <a:r>
-              <a:t>Điều chỉnh trợ cấp theo biến động xăng</a:t>
-            </a:r>
+              <a:rPr dirty="0" err="1"/>
+              <a:t>Điều</a:t>
+            </a:r>
+            <a:r>
+              <a:rPr dirty="0"/>
+              <a:t> </a:t>
+            </a:r>
+            <a:r>
+              <a:rPr dirty="0" err="1"/>
+              <a:t>chỉnh</a:t>
+            </a:r>
+            <a:r>
+              <a:rPr dirty="0"/>
+              <a:t> </a:t>
+            </a:r>
+            <a:r>
+              <a:rPr dirty="0" err="1"/>
+              <a:t>trợ</a:t>
+            </a:r>
+            <a:r>
+              <a:rPr dirty="0"/>
+              <a:t> </a:t>
+            </a:r>
+            <a:r>
+              <a:rPr dirty="0" err="1"/>
+              <a:t>cấp</a:t>
+            </a:r>
+            <a:r>
+              <a:rPr dirty="0"/>
+              <a:t> </a:t>
+            </a:r>
+            <a:r>
+              <a:rPr dirty="0" err="1"/>
+              <a:t>theo</a:t>
+            </a:r>
+            <a:r>
+              <a:rPr dirty="0"/>
+              <a:t> </a:t>
+            </a:r>
+            <a:r>
+              <a:rPr dirty="0" err="1"/>
+              <a:t>biến</a:t>
+            </a:r>
+            <a:r>
+              <a:rPr dirty="0"/>
+              <a:t> </a:t>
+            </a:r>
+            <a:r>
+              <a:rPr dirty="0" err="1"/>
+              <a:t>động</a:t>
+            </a:r>
+            <a:r>
+              <a:rPr dirty="0"/>
+              <a:t> </a:t>
+            </a:r>
+            <a:r>
+              <a:rPr dirty="0" err="1"/>
+              <a:t>xăng</a:t>
+            </a:r>
+            <a:endParaRPr dirty="0"/>
           </a:p>
         </p:txBody>
       </p:sp>
@@ -14928,7 +13672,52 @@
               </a:defRPr>
             </a:pPr>
             <a:r>
-              <a:t>Mở rộng khách hàng nội địa VN</a:t>
+              <a:rPr dirty="0" err="1"/>
+              <a:t>Mở</a:t>
+            </a:r>
+            <a:r>
+              <a:rPr dirty="0"/>
+              <a:t> </a:t>
+            </a:r>
+            <a:r>
+              <a:rPr dirty="0" err="1"/>
+              <a:t>rộng</a:t>
+            </a:r>
+            <a:r>
+              <a:rPr dirty="0"/>
+              <a:t> </a:t>
+            </a:r>
+            <a:r>
+              <a:rPr dirty="0" err="1"/>
+              <a:t>khách</a:t>
+            </a:r>
+            <a:r>
+              <a:rPr dirty="0"/>
+              <a:t> </a:t>
+            </a:r>
+            <a:r>
+              <a:rPr dirty="0" err="1"/>
+              <a:t>hàng</a:t>
+            </a:r>
+            <a:r>
+              <a:rPr dirty="0"/>
+              <a:t> </a:t>
+            </a:r>
+            <a:r>
+              <a:rPr dirty="0" err="1"/>
+              <a:t>nội</a:t>
+            </a:r>
+            <a:r>
+              <a:rPr dirty="0"/>
+              <a:t> </a:t>
+            </a:r>
+            <a:r>
+              <a:rPr dirty="0" err="1"/>
+              <a:t>địa</a:t>
+            </a:r>
+            <a:r>
+              <a:rPr dirty="0"/>
+              <a:t> VN</a:t>
             </a:r>
           </a:p>
         </p:txBody>
@@ -14986,7 +13775,7 @@
         <p:spPr>
           <a:xfrm>
             <a:off x="6766560" y="3108960"/>
-            <a:ext cx="2011680" cy="548640"/>
+            <a:ext cx="2011680" cy="461665"/>
           </a:xfrm>
           <a:prstGeom prst="rect">
             <a:avLst/>
@@ -15007,8 +13796,54 @@
               </a:defRPr>
             </a:pPr>
             <a:r>
-              <a:t>Giảm phụ thuộc vào tập đoàn mẹ</a:t>
-            </a:r>
+              <a:rPr dirty="0" err="1"/>
+              <a:t>Giảm</a:t>
+            </a:r>
+            <a:r>
+              <a:rPr dirty="0"/>
+              <a:t> </a:t>
+            </a:r>
+            <a:r>
+              <a:rPr dirty="0" err="1"/>
+              <a:t>phụ</a:t>
+            </a:r>
+            <a:r>
+              <a:rPr dirty="0"/>
+              <a:t> </a:t>
+            </a:r>
+            <a:r>
+              <a:rPr dirty="0" err="1"/>
+              <a:t>thuộc</a:t>
+            </a:r>
+            <a:r>
+              <a:rPr dirty="0"/>
+              <a:t> </a:t>
+            </a:r>
+            <a:r>
+              <a:rPr dirty="0" err="1"/>
+              <a:t>vào</a:t>
+            </a:r>
+            <a:r>
+              <a:rPr lang="en-US" dirty="0"/>
+              <a:t> </a:t>
+            </a:r>
+            <a:r>
+              <a:rPr lang="en-US" dirty="0" err="1"/>
+              <a:t>công</a:t>
+            </a:r>
+            <a:r>
+              <a:rPr lang="en-US" dirty="0"/>
+              <a:t> ty</a:t>
+            </a:r>
+            <a:r>
+              <a:rPr dirty="0"/>
+              <a:t> </a:t>
+            </a:r>
+            <a:r>
+              <a:rPr dirty="0" err="1"/>
+              <a:t>mẹ</a:t>
+            </a:r>
+            <a:endParaRPr dirty="0"/>
           </a:p>
         </p:txBody>
       </p:sp>
@@ -15086,8 +13921,34 @@
               </a:defRPr>
             </a:pPr>
             <a:r>
-              <a:t>Xây pipeline dự án 3-6 tháng</a:t>
-            </a:r>
+              <a:rPr dirty="0" err="1"/>
+              <a:t>Xây</a:t>
+            </a:r>
+            <a:r>
+              <a:rPr dirty="0"/>
+              <a:t> pipeline </a:t>
+            </a:r>
+            <a:r>
+              <a:rPr dirty="0" err="1"/>
+              <a:t>dự</a:t>
+            </a:r>
+            <a:r>
+              <a:rPr dirty="0"/>
+              <a:t> </a:t>
+            </a:r>
+            <a:r>
+              <a:rPr dirty="0" err="1"/>
+              <a:t>án</a:t>
+            </a:r>
+            <a:r>
+              <a:rPr dirty="0"/>
+              <a:t> 3-6 </a:t>
+            </a:r>
+            <a:r>
+              <a:rPr dirty="0" err="1"/>
+              <a:t>tháng</a:t>
+            </a:r>
+            <a:endParaRPr dirty="0"/>
           </a:p>
         </p:txBody>
       </p:sp>
@@ -15404,7 +14265,7 @@
         <p:spPr>
           <a:xfrm>
             <a:off x="9692640" y="2468880"/>
-            <a:ext cx="2011680" cy="548640"/>
+            <a:ext cx="2011680" cy="276999"/>
           </a:xfrm>
           <a:prstGeom prst="rect">
             <a:avLst/>
@@ -15425,8 +14286,30 @@
               </a:defRPr>
             </a:pPr>
             <a:r>
-              <a:t>Đào tạo chuyên sâu BIM (Autodesk/BSI)</a:t>
-            </a:r>
+              <a:rPr dirty="0"/>
+              <a:t>Đào </a:t>
+            </a:r>
+            <a:r>
+              <a:rPr dirty="0" err="1"/>
+              <a:t>tạo</a:t>
+            </a:r>
+            <a:r>
+              <a:rPr dirty="0"/>
+              <a:t> </a:t>
+            </a:r>
+            <a:r>
+              <a:rPr dirty="0" err="1"/>
+              <a:t>chuyên</a:t>
+            </a:r>
+            <a:r>
+              <a:rPr dirty="0"/>
+              <a:t> </a:t>
+            </a:r>
+            <a:r>
+              <a:rPr dirty="0" err="1"/>
+              <a:t>sâu</a:t>
+            </a:r>
+            <a:endParaRPr dirty="0"/>
           </a:p>
         </p:txBody>
       </p:sp>
@@ -15483,7 +14366,7 @@
         <p:spPr>
           <a:xfrm>
             <a:off x="9692640" y="3108960"/>
-            <a:ext cx="2011680" cy="548640"/>
+            <a:ext cx="2011680" cy="276999"/>
           </a:xfrm>
           <a:prstGeom prst="rect">
             <a:avLst/>
@@ -15504,87 +14387,50 @@
               </a:defRPr>
             </a:pPr>
             <a:r>
-              <a:t>Dẫn đầu BIM outsourcing tại VN</a:t>
-            </a:r>
-          </a:p>
-        </p:txBody>
-      </p:sp>
-      <p:sp>
-        <p:nvSpPr>
-          <p:cNvPr id="48" name="Oval 47"/>
-          <p:cNvSpPr/>
-          <p:nvPr/>
-        </p:nvSpPr>
-        <p:spPr>
-          <a:xfrm>
-            <a:off x="9418320" y="3794760"/>
-            <a:ext cx="164592" cy="164592"/>
-          </a:xfrm>
-          <a:prstGeom prst="ellipse">
-            <a:avLst/>
-          </a:prstGeom>
-          <a:solidFill>
-            <a:srgbClr val="1B8A4B"/>
-          </a:solidFill>
-          <a:ln>
-            <a:noFill/>
-          </a:ln>
-        </p:spPr>
-        <p:style>
-          <a:lnRef idx="1">
-            <a:schemeClr val="accent1"/>
-          </a:lnRef>
-          <a:fillRef idx="3">
-            <a:schemeClr val="accent1"/>
-          </a:fillRef>
-          <a:effectRef idx="2">
-            <a:schemeClr val="accent1"/>
-          </a:effectRef>
-          <a:fontRef idx="minor">
-            <a:schemeClr val="lt1"/>
-          </a:fontRef>
-        </p:style>
-        <p:txBody>
-          <a:bodyPr rtlCol="0" anchor="ctr"/>
-          <a:lstStyle/>
-          <a:p>
-            <a:pPr algn="ctr"/>
-            <a:endParaRPr/>
-          </a:p>
-        </p:txBody>
-      </p:sp>
-      <p:sp>
-        <p:nvSpPr>
-          <p:cNvPr id="49" name="TextBox 48"/>
-          <p:cNvSpPr txBox="1"/>
-          <p:nvPr/>
-        </p:nvSpPr>
-        <p:spPr>
-          <a:xfrm>
-            <a:off x="9692640" y="3749040"/>
-            <a:ext cx="2011680" cy="548640"/>
-          </a:xfrm>
-          <a:prstGeom prst="rect">
-            <a:avLst/>
-          </a:prstGeom>
-          <a:noFill/>
-        </p:spPr>
-        <p:txBody>
-          <a:bodyPr wrap="square">
-            <a:spAutoFit/>
-          </a:bodyPr>
-          <a:lstStyle/>
-          <a:p>
-            <a:pPr algn="l">
-              <a:defRPr sz="1200" b="0">
-                <a:solidFill>
-                  <a:srgbClr val="2D3A4A"/>
-                </a:solidFill>
-              </a:defRPr>
-            </a:pPr>
-            <a:r>
-              <a:t>Case study, hợp tác trường ĐH</a:t>
-            </a:r>
+              <a:rPr lang="en-US" dirty="0" err="1"/>
+              <a:t>Mở</a:t>
+            </a:r>
+            <a:r>
+              <a:rPr lang="en-US" dirty="0"/>
+              <a:t> </a:t>
+            </a:r>
+            <a:r>
+              <a:rPr lang="en-US" dirty="0" err="1"/>
+              <a:t>rộng</a:t>
+            </a:r>
+            <a:r>
+              <a:rPr lang="en-US" dirty="0"/>
+              <a:t> </a:t>
+            </a:r>
+            <a:r>
+              <a:rPr lang="en-US" dirty="0" err="1"/>
+              <a:t>thị</a:t>
+            </a:r>
+            <a:r>
+              <a:rPr lang="en-US" dirty="0"/>
+              <a:t> </a:t>
+            </a:r>
+            <a:r>
+              <a:rPr lang="en-US" dirty="0" err="1"/>
+              <a:t>phần</a:t>
+            </a:r>
+            <a:r>
+              <a:rPr lang="en-US" dirty="0"/>
+              <a:t> </a:t>
+            </a:r>
+            <a:r>
+              <a:rPr lang="en-US" dirty="0" err="1"/>
+              <a:t>khách</a:t>
+            </a:r>
+            <a:r>
+              <a:rPr lang="en-US" dirty="0"/>
+              <a:t> </a:t>
+            </a:r>
+            <a:r>
+              <a:rPr lang="en-US" dirty="0" err="1"/>
+              <a:t>hàng</a:t>
+            </a:r>
+            <a:endParaRPr dirty="0"/>
           </a:p>
         </p:txBody>
       </p:sp>

</xml_diff>

<commit_message>
vault backup: 2026-05-17 08:09:06
</commit_message>
<xml_diff>
--- a/01_Courses/01_Active/00_BSKT/01_Quan Tri Hoc/07_AI-Workspace/Outputs/thuyet-trinh-bien-dong-gia.pptx
+++ b/01_Courses/01_Active/00_BSKT/01_Quan Tri Hoc/07_AI-Workspace/Outputs/thuyet-trinh-bien-dong-gia.pptx
@@ -9827,7 +9827,7 @@
         <p:spPr>
           <a:xfrm>
             <a:off x="2743200" y="4983480"/>
-            <a:ext cx="3154680" cy="1280160"/>
+            <a:ext cx="3154680" cy="646331"/>
           </a:xfrm>
           <a:prstGeom prst="rect">
             <a:avLst/>
@@ -9848,16 +9848,112 @@
               </a:defRPr>
             </a:pPr>
             <a:r>
-              <a:t>Chi phí vay vốn tăng</a:t>
-            </a:r>
-            <a:br/>
-            <a:r>
-              <a:t>(license, thiết bị, mặt bằng)</a:t>
-            </a:r>
-            <a:br/>
-            <a:r>
-              <a:t>→ Ăn vào biên lợi nhuận</a:t>
-            </a:r>
+              <a:rPr dirty="0"/>
+              <a:t>Chi </a:t>
+            </a:r>
+            <a:r>
+              <a:rPr dirty="0" err="1"/>
+              <a:t>phí</a:t>
+            </a:r>
+            <a:r>
+              <a:rPr dirty="0"/>
+              <a:t> </a:t>
+            </a:r>
+            <a:r>
+              <a:rPr dirty="0" err="1"/>
+              <a:t>vay</a:t>
+            </a:r>
+            <a:r>
+              <a:rPr dirty="0"/>
+              <a:t> </a:t>
+            </a:r>
+            <a:r>
+              <a:rPr dirty="0" err="1"/>
+              <a:t>vốn</a:t>
+            </a:r>
+            <a:r>
+              <a:rPr dirty="0"/>
+              <a:t> </a:t>
+            </a:r>
+            <a:r>
+              <a:rPr dirty="0" err="1"/>
+              <a:t>tăng</a:t>
+            </a:r>
+            <a:br>
+              <a:rPr dirty="0"/>
+            </a:br>
+            <a:r>
+              <a:rPr dirty="0"/>
+              <a:t>(license, </a:t>
+            </a:r>
+            <a:r>
+              <a:rPr dirty="0" err="1"/>
+              <a:t>thiết</a:t>
+            </a:r>
+            <a:r>
+              <a:rPr dirty="0"/>
+              <a:t> </a:t>
+            </a:r>
+            <a:r>
+              <a:rPr dirty="0" err="1"/>
+              <a:t>bị</a:t>
+            </a:r>
+            <a:r>
+              <a:rPr dirty="0"/>
+              <a:t>, </a:t>
+            </a:r>
+            <a:r>
+              <a:rPr dirty="0" err="1"/>
+              <a:t>mặt</a:t>
+            </a:r>
+            <a:r>
+              <a:rPr dirty="0"/>
+              <a:t> </a:t>
+            </a:r>
+            <a:r>
+              <a:rPr dirty="0" err="1"/>
+              <a:t>bằng</a:t>
+            </a:r>
+            <a:r>
+              <a:rPr dirty="0"/>
+              <a:t>)</a:t>
+            </a:r>
+            <a:br>
+              <a:rPr dirty="0"/>
+            </a:br>
+            <a:r>
+              <a:rPr dirty="0"/>
+              <a:t>→ </a:t>
+            </a:r>
+            <a:r>
+              <a:rPr dirty="0" err="1"/>
+              <a:t>Ăn</a:t>
+            </a:r>
+            <a:r>
+              <a:rPr dirty="0"/>
+              <a:t> </a:t>
+            </a:r>
+            <a:r>
+              <a:rPr dirty="0" err="1"/>
+              <a:t>vào</a:t>
+            </a:r>
+            <a:r>
+              <a:rPr dirty="0"/>
+              <a:t> </a:t>
+            </a:r>
+            <a:r>
+              <a:rPr dirty="0" err="1"/>
+              <a:t>lợi</a:t>
+            </a:r>
+            <a:r>
+              <a:rPr dirty="0"/>
+              <a:t> </a:t>
+            </a:r>
+            <a:r>
+              <a:rPr dirty="0" err="1"/>
+              <a:t>nhuận</a:t>
+            </a:r>
+            <a:endParaRPr dirty="0"/>
           </a:p>
         </p:txBody>
       </p:sp>
@@ -11564,11 +11660,17 @@
           <p:cNvGraphicFramePr>
             <a:graphicFrameLocks noGrp="1"/>
           </p:cNvGraphicFramePr>
-          <p:nvPr/>
+          <p:nvPr>
+            <p:extLst>
+              <p:ext uri="{D42A27DB-BD31-4B8C-83A1-F6EECF244321}">
+                <p14:modId xmlns:p14="http://schemas.microsoft.com/office/powerpoint/2010/main" val="695336305"/>
+              </p:ext>
+            </p:extLst>
+          </p:nvPr>
         </p:nvGraphicFramePr>
         <p:xfrm>
-          <a:off x="548640" y="1463040"/>
-          <a:ext cx="11064240" cy="5029200"/>
+          <a:off x="2103120" y="1463040"/>
+          <a:ext cx="8686800" cy="5029200"/>
         </p:xfrm>
         <a:graphic>
           <a:graphicData uri="http://schemas.openxmlformats.org/drawingml/2006/table">
@@ -11602,13 +11704,6 @@
                   <a:extLst>
                     <a:ext uri="{9D8B030D-6E8A-4147-A177-3AD203B41FA5}">
                       <a16:colId xmlns:a16="http://schemas.microsoft.com/office/drawing/2014/main" val="20003"/>
-                    </a:ext>
-                  </a:extLst>
-                </a:gridCol>
-                <a:gridCol w="2377440">
-                  <a:extLst>
-                    <a:ext uri="{9D8B030D-6E8A-4147-A177-3AD203B41FA5}">
-                      <a16:colId xmlns:a16="http://schemas.microsoft.com/office/drawing/2014/main" val="20004"/>
                     </a:ext>
                   </a:extLst>
                 </a:gridCol>
@@ -11697,29 +11792,6 @@
                       </a:pPr>
                       <a:r>
                         <a:t>Tính chất</a:t>
-                      </a:r>
-                    </a:p>
-                  </a:txBody>
-                  <a:tcPr anchor="ctr">
-                    <a:solidFill>
-                      <a:srgbClr val="1B3A5C"/>
-                    </a:solidFill>
-                  </a:tcPr>
-                </a:tc>
-                <a:tc>
-                  <a:txBody>
-                    <a:bodyPr/>
-                    <a:lstStyle/>
-                    <a:p>
-                      <a:pPr algn="ctr">
-                        <a:defRPr sz="1400" b="1">
-                          <a:solidFill>
-                            <a:srgbClr val="FFFFFF"/>
-                          </a:solidFill>
-                        </a:defRPr>
-                      </a:pPr>
-                      <a:r>
-                        <a:t>Quản trị ưu tiên</a:t>
                       </a:r>
                     </a:p>
                   </a:txBody>
@@ -11840,41 +11912,6 @@
                     </a:solidFill>
                   </a:tcPr>
                 </a:tc>
-                <a:tc>
-                  <a:txBody>
-                    <a:bodyPr/>
-                    <a:lstStyle/>
-                    <a:p>
-                      <a:pPr>
-                        <a:defRPr sz="1200">
-                          <a:solidFill>
-                            <a:srgbClr val="2D3A4A"/>
-                          </a:solidFill>
-                        </a:defRPr>
-                      </a:pPr>
-                      <a:r>
-                        <a:t>Hedge tỷ giá,</a:t>
-                      </a:r>
-                    </a:p>
-                    <a:p>
-                      <a:pPr>
-                        <a:defRPr sz="1200">
-                          <a:solidFill>
-                            <a:srgbClr val="2D3A4A"/>
-                          </a:solidFill>
-                        </a:defRPr>
-                      </a:pPr>
-                      <a:r>
-                        <a:t>điều khoản hợp đồng</a:t>
-                      </a:r>
-                    </a:p>
-                  </a:txBody>
-                  <a:tcPr anchor="ctr">
-                    <a:solidFill>
-                      <a:srgbClr val="FEF9E7"/>
-                    </a:solidFill>
-                  </a:tcPr>
-                </a:tc>
                 <a:extLst>
                   <a:ext uri="{0D108BD9-81ED-4DB2-BD59-A6C34878D82A}">
                     <a16:rowId xmlns:a16="http://schemas.microsoft.com/office/drawing/2014/main" val="10001"/>
@@ -11977,41 +12014,6 @@
                       </a:pPr>
                       <a:r>
                         <a:t>Trực tiếp</a:t>
-                      </a:r>
-                    </a:p>
-                  </a:txBody>
-                  <a:tcPr anchor="ctr">
-                    <a:solidFill>
-                      <a:srgbClr val="FDF2E9"/>
-                    </a:solidFill>
-                  </a:tcPr>
-                </a:tc>
-                <a:tc>
-                  <a:txBody>
-                    <a:bodyPr/>
-                    <a:lstStyle/>
-                    <a:p>
-                      <a:pPr>
-                        <a:defRPr sz="1200">
-                          <a:solidFill>
-                            <a:srgbClr val="2D3A4A"/>
-                          </a:solidFill>
-                        </a:defRPr>
-                      </a:pPr>
-                      <a:r>
-                        <a:t>Hybrid work,</a:t>
-                      </a:r>
-                    </a:p>
-                    <a:p>
-                      <a:pPr>
-                        <a:defRPr sz="1200">
-                          <a:solidFill>
-                            <a:srgbClr val="2D3A4A"/>
-                          </a:solidFill>
-                        </a:defRPr>
-                      </a:pPr>
-                      <a:r>
-                        <a:t>tái cấu trúc phụ cấp</a:t>
                       </a:r>
                     </a:p>
                   </a:txBody>
@@ -12132,41 +12134,6 @@
                     </a:solidFill>
                   </a:tcPr>
                 </a:tc>
-                <a:tc>
-                  <a:txBody>
-                    <a:bodyPr/>
-                    <a:lstStyle/>
-                    <a:p>
-                      <a:pPr>
-                        <a:defRPr sz="1200">
-                          <a:solidFill>
-                            <a:srgbClr val="2D3A4A"/>
-                          </a:solidFill>
-                        </a:defRPr>
-                      </a:pPr>
-                      <a:r>
-                        <a:t>Đa dạng hóa</a:t>
-                      </a:r>
-                    </a:p>
-                    <a:p>
-                      <a:pPr>
-                        <a:defRPr sz="1200">
-                          <a:solidFill>
-                            <a:srgbClr val="2D3A4A"/>
-                          </a:solidFill>
-                        </a:defRPr>
-                      </a:pPr>
-                      <a:r>
-                        <a:t>nguồn việc &amp; khách</a:t>
-                      </a:r>
-                    </a:p>
-                  </a:txBody>
-                  <a:tcPr anchor="ctr">
-                    <a:solidFill>
-                      <a:srgbClr val="FDEDEC"/>
-                    </a:solidFill>
-                  </a:tcPr>
-                </a:tc>
                 <a:extLst>
                   <a:ext uri="{0D108BD9-81ED-4DB2-BD59-A6C34878D82A}">
                     <a16:rowId xmlns:a16="http://schemas.microsoft.com/office/drawing/2014/main" val="10003"/>
@@ -12187,7 +12154,16 @@
                         </a:defRPr>
                       </a:pPr>
                       <a:r>
-                        <a:t>Xu hướng CĐS</a:t>
+                        <a:rPr dirty="0"/>
+                        <a:t>Xu </a:t>
+                      </a:r>
+                      <a:r>
+                        <a:rPr dirty="0" err="1"/>
+                        <a:t>hướng</a:t>
+                      </a:r>
+                      <a:r>
+                        <a:rPr dirty="0"/>
+                        <a:t> CĐS</a:t>
                       </a:r>
                     </a:p>
                   </a:txBody>
@@ -12268,43 +12244,18 @@
                         </a:defRPr>
                       </a:pPr>
                       <a:r>
-                        <a:t>Trực tiếp</a:t>
+                        <a:rPr dirty="0" err="1"/>
+                        <a:t>Trực</a:t>
                       </a:r>
-                    </a:p>
-                  </a:txBody>
-                  <a:tcPr anchor="ctr">
-                    <a:solidFill>
-                      <a:srgbClr val="E8F8F5"/>
-                    </a:solidFill>
-                  </a:tcPr>
-                </a:tc>
-                <a:tc>
-                  <a:txBody>
-                    <a:bodyPr/>
-                    <a:lstStyle/>
-                    <a:p>
-                      <a:pPr>
-                        <a:defRPr sz="1200">
-                          <a:solidFill>
-                            <a:srgbClr val="2D3A4A"/>
-                          </a:solidFill>
-                        </a:defRPr>
-                      </a:pPr>
                       <a:r>
-                        <a:t>Đầu tư năng lực,</a:t>
+                        <a:rPr dirty="0"/>
+                        <a:t> </a:t>
                       </a:r>
-                    </a:p>
-                    <a:p>
-                      <a:pPr>
-                        <a:defRPr sz="1200">
-                          <a:solidFill>
-                            <a:srgbClr val="2D3A4A"/>
-                          </a:solidFill>
-                        </a:defRPr>
-                      </a:pPr>
                       <a:r>
-                        <a:t>định vị thương hiệu</a:t>
+                        <a:rPr dirty="0" err="1"/>
+                        <a:t>tiếp</a:t>
                       </a:r>
+                      <a:endParaRPr dirty="0"/>
                     </a:p>
                   </a:txBody>
                   <a:tcPr anchor="ctr">

</xml_diff>